<commit_message>
PPT fixes and version alignment
</commit_message>
<xml_diff>
--- a/Week 8/Project 5/Ravenstack_Churn_Pitch_v2.pptx
+++ b/Week 8/Project 5/Ravenstack_Churn_Pitch_v2.pptx
@@ -8,7 +8,7 @@
     <p:notesMasterId r:id="rId9"/>
   </p:notesMasterIdLst>
   <p:sldIdLst>
-    <p:sldId id="256" r:id="rId2"/>
+    <p:sldId id="263" r:id="rId2"/>
     <p:sldId id="257" r:id="rId3"/>
     <p:sldId id="258" r:id="rId4"/>
     <p:sldId id="260" r:id="rId5"/>
@@ -116,6 +116,15 @@
     </p:ext>
   </p:extLst>
 </p:presentation>
+</file>
+
+<file path=ppt/revisionInfo.xml><?xml version="1.0" encoding="utf-8"?>
+<p1510:revInfo xmlns:a="http://schemas.openxmlformats.org/drawingml/2006/main" xmlns:r="http://schemas.openxmlformats.org/officeDocument/2006/relationships" xmlns:p1510="http://schemas.microsoft.com/office/powerpoint/2015/10/main">
+  <p1510:revLst>
+    <p1510:client id="{76583AEA-5D2E-F531-D6A9-013C67BF1A68}" v="23" dt="2026-06-11T14:30:56.498"/>
+    <p1510:client id="{9CE7963D-D35D-D348-A88F-B6F144D0F21E}" v="13" dt="2026-06-11T13:10:36.199"/>
+  </p1510:revLst>
+</p1510:revInfo>
 </file>
 
 <file path=ppt/notesMasters/notesMaster1.xml><?xml version="1.0" encoding="utf-8"?>
@@ -248,7 +257,13 @@
   <p:cSld>
     <p:spTree>
       <p:nvGrpSpPr>
-        <p:cNvPr id="1" name=""/>
+        <p:cNvPr id="1" name="">
+          <a:extLst>
+            <a:ext uri="{FF2B5EF4-FFF2-40B4-BE49-F238E27FC236}">
+              <a16:creationId xmlns:a16="http://schemas.microsoft.com/office/drawing/2014/main" id="{26DD5253-F2E3-0764-92AC-0BB82D6BD000}"/>
+            </a:ext>
+          </a:extLst>
+        </p:cNvPr>
         <p:cNvGrpSpPr/>
         <p:nvPr/>
       </p:nvGrpSpPr>
@@ -262,7 +277,13 @@
       </p:grpSpPr>
       <p:sp>
         <p:nvSpPr>
-          <p:cNvPr id="2" name="Slide Image Placeholder 1"/>
+          <p:cNvPr id="2" name="Slide Image Placeholder 1">
+            <a:extLst>
+              <a:ext uri="{FF2B5EF4-FFF2-40B4-BE49-F238E27FC236}">
+                <a16:creationId xmlns:a16="http://schemas.microsoft.com/office/drawing/2014/main" id="{43A3B02C-5230-9F03-C743-750CCA60C3FB}"/>
+              </a:ext>
+            </a:extLst>
+          </p:cNvPr>
           <p:cNvSpPr>
             <a:spLocks noGrp="1" noRot="1" noChangeAspect="1"/>
           </p:cNvSpPr>
@@ -274,7 +295,13 @@
       </p:sp>
       <p:sp>
         <p:nvSpPr>
-          <p:cNvPr id="3" name="Notes Placeholder 2"/>
+          <p:cNvPr id="3" name="Notes Placeholder 2">
+            <a:extLst>
+              <a:ext uri="{FF2B5EF4-FFF2-40B4-BE49-F238E27FC236}">
+                <a16:creationId xmlns:a16="http://schemas.microsoft.com/office/drawing/2014/main" id="{71658FF4-B6AC-49AA-4C2D-FF6562807C6A}"/>
+              </a:ext>
+            </a:extLst>
+          </p:cNvPr>
           <p:cNvSpPr>
             <a:spLocks noGrp="1"/>
           </p:cNvSpPr>
@@ -293,7 +320,13 @@
       </p:sp>
       <p:sp>
         <p:nvSpPr>
-          <p:cNvPr id="4" name="Slide Number Placeholder 3"/>
+          <p:cNvPr id="4" name="Slide Number Placeholder 3">
+            <a:extLst>
+              <a:ext uri="{FF2B5EF4-FFF2-40B4-BE49-F238E27FC236}">
+                <a16:creationId xmlns:a16="http://schemas.microsoft.com/office/drawing/2014/main" id="{95FF0EB8-C3F0-F097-8256-3B6DA49EE566}"/>
+              </a:ext>
+            </a:extLst>
+          </p:cNvPr>
           <p:cNvSpPr>
             <a:spLocks noGrp="1"/>
           </p:cNvSpPr>
@@ -317,7 +350,7 @@
     </p:spTree>
     <p:extLst>
       <p:ext uri="{BB962C8B-B14F-4D97-AF65-F5344CB8AC3E}">
-        <p14:creationId xmlns:p14="http://schemas.microsoft.com/office/powerpoint/2010/main" val="1024086991"/>
+        <p14:creationId xmlns:p14="http://schemas.microsoft.com/office/powerpoint/2010/main" val="2807361784"/>
       </p:ext>
     </p:extLst>
   </p:cSld>
@@ -1145,7 +1178,7 @@
 
 <file path=ppt/slides/slide1.xml><?xml version="1.0" encoding="utf-8"?>
 <p:sld xmlns:a="http://schemas.openxmlformats.org/drawingml/2006/main" xmlns:r="http://schemas.openxmlformats.org/officeDocument/2006/relationships" xmlns:p="http://schemas.openxmlformats.org/presentationml/2006/main">
-  <p:cSld name="Slide 1">
+  <p:cSld>
     <p:bg>
       <p:bgPr>
         <a:solidFill>
@@ -1156,7 +1189,13 @@
     </p:bg>
     <p:spTree>
       <p:nvGrpSpPr>
-        <p:cNvPr id="1" name=""/>
+        <p:cNvPr id="1" name="">
+          <a:extLst>
+            <a:ext uri="{FF2B5EF4-FFF2-40B4-BE49-F238E27FC236}">
+              <a16:creationId xmlns:a16="http://schemas.microsoft.com/office/drawing/2014/main" id="{341EFF32-A63E-373E-092C-AF4B14B96F15}"/>
+            </a:ext>
+          </a:extLst>
+        </p:cNvPr>
         <p:cNvGrpSpPr/>
         <p:nvPr/>
       </p:nvGrpSpPr>
@@ -1170,7 +1209,13 @@
       </p:grpSpPr>
       <p:sp>
         <p:nvSpPr>
-          <p:cNvPr id="2" name="Shape 0"/>
+          <p:cNvPr id="2" name="Shape 0">
+            <a:extLst>
+              <a:ext uri="{FF2B5EF4-FFF2-40B4-BE49-F238E27FC236}">
+                <a16:creationId xmlns:a16="http://schemas.microsoft.com/office/drawing/2014/main" id="{5D5FFC24-6B6D-FC95-5D5E-A8257673224E}"/>
+              </a:ext>
+            </a:extLst>
+          </p:cNvPr>
           <p:cNvSpPr/>
           <p:nvPr/>
         </p:nvSpPr>
@@ -1202,7 +1247,13 @@
       </p:sp>
       <p:sp>
         <p:nvSpPr>
-          <p:cNvPr id="3" name="Text 1"/>
+          <p:cNvPr id="3" name="Text 1">
+            <a:extLst>
+              <a:ext uri="{FF2B5EF4-FFF2-40B4-BE49-F238E27FC236}">
+                <a16:creationId xmlns:a16="http://schemas.microsoft.com/office/drawing/2014/main" id="{EAB3DF02-C9DA-831C-3D8E-0BBA6D05D93B}"/>
+              </a:ext>
+            </a:extLst>
+          </p:cNvPr>
           <p:cNvSpPr/>
           <p:nvPr/>
         </p:nvSpPr>
@@ -1220,6 +1271,42 @@
         <p:txBody>
           <a:bodyPr wrap="square" lIns="0" tIns="0" rIns="0" bIns="0" rtlCol="0" anchor="ctr"/>
           <a:lstStyle/>
+          <a:p>
+            <a:pPr>
+              <a:lnSpc>
+                <a:spcPct val="110000"/>
+              </a:lnSpc>
+              <a:spcAft>
+                <a:spcPts val="600"/>
+              </a:spcAft>
+            </a:pPr>
+            <a:r>
+              <a:rPr lang="en-US" sz="4600" b="1" dirty="0" err="1">
+                <a:solidFill>
+                  <a:srgbClr val="FFFFFF"/>
+                </a:solidFill>
+                <a:latin typeface="Cambria"/>
+                <a:ea typeface="Cambria"/>
+                <a:cs typeface="Cambria" pitchFamily="34" charset="-120"/>
+              </a:rPr>
+              <a:t>Ravenstack</a:t>
+            </a:r>
+            <a:r>
+              <a:rPr lang="en-US" sz="4600" b="1" dirty="0">
+                <a:solidFill>
+                  <a:srgbClr val="FFFFFF"/>
+                </a:solidFill>
+                <a:latin typeface="Cambria"/>
+                <a:ea typeface="Cambria"/>
+                <a:cs typeface="Cambria" pitchFamily="34" charset="-120"/>
+              </a:rPr>
+              <a:t> has lost  </a:t>
+            </a:r>
+            <a:endParaRPr lang="en-US" sz="4600" dirty="0">
+              <a:latin typeface="Cambria"/>
+              <a:ea typeface="Cambria"/>
+            </a:endParaRPr>
+          </a:p>
           <a:p>
             <a:pPr marL="0" indent="0" algn="l">
               <a:lnSpc>
@@ -1239,38 +1326,21 @@
                 <a:ea typeface="Cambria" pitchFamily="34" charset="-122"/>
                 <a:cs typeface="Cambria" pitchFamily="34" charset="-120"/>
               </a:rPr>
-              <a:t>Ravenstack is losing </a:t>
+              <a:t>$14.1M to churn.</a:t>
             </a:r>
             <a:endParaRPr lang="en-US" sz="4600" dirty="0"/>
           </a:p>
-          <a:p>
-            <a:pPr marL="0" indent="0" algn="l">
-              <a:lnSpc>
-                <a:spcPct val="110000"/>
-              </a:lnSpc>
-              <a:spcAft>
-                <a:spcPts val="600"/>
-              </a:spcAft>
-              <a:buNone/>
-            </a:pPr>
-            <a:r>
-              <a:rPr lang="en-US" sz="4600" b="1" dirty="0">
-                <a:solidFill>
-                  <a:srgbClr val="FFFFFF"/>
-                </a:solidFill>
-                <a:latin typeface="Cambria" pitchFamily="34" charset="0"/>
-                <a:ea typeface="Cambria" pitchFamily="34" charset="-122"/>
-                <a:cs typeface="Cambria" pitchFamily="34" charset="-120"/>
-              </a:rPr>
-              <a:t>$14.1M to churn.</a:t>
-            </a:r>
-            <a:endParaRPr lang="en-US" sz="4600" dirty="0"/>
-          </a:p>
-        </p:txBody>
-      </p:sp>
-      <p:sp>
-        <p:nvSpPr>
-          <p:cNvPr id="4" name="Text 2"/>
+        </p:txBody>
+      </p:sp>
+      <p:sp>
+        <p:nvSpPr>
+          <p:cNvPr id="4" name="Text 2">
+            <a:extLst>
+              <a:ext uri="{FF2B5EF4-FFF2-40B4-BE49-F238E27FC236}">
+                <a16:creationId xmlns:a16="http://schemas.microsoft.com/office/drawing/2014/main" id="{83990149-0EED-821A-2FB2-E5162540FFDC}"/>
+              </a:ext>
+            </a:extLst>
+          </p:cNvPr>
           <p:cNvSpPr/>
           <p:nvPr/>
         </p:nvSpPr>
@@ -1309,7 +1379,13 @@
       </p:sp>
       <p:sp>
         <p:nvSpPr>
-          <p:cNvPr id="5" name="Shape 3"/>
+          <p:cNvPr id="5" name="Shape 3">
+            <a:extLst>
+              <a:ext uri="{FF2B5EF4-FFF2-40B4-BE49-F238E27FC236}">
+                <a16:creationId xmlns:a16="http://schemas.microsoft.com/office/drawing/2014/main" id="{BA18F47C-2CC9-EDBE-3028-5AEC148FEE2B}"/>
+              </a:ext>
+            </a:extLst>
+          </p:cNvPr>
           <p:cNvSpPr/>
           <p:nvPr/>
         </p:nvSpPr>
@@ -1339,7 +1415,13 @@
       </p:sp>
       <p:sp>
         <p:nvSpPr>
-          <p:cNvPr id="6" name="Text 4"/>
+          <p:cNvPr id="6" name="Text 4">
+            <a:extLst>
+              <a:ext uri="{FF2B5EF4-FFF2-40B4-BE49-F238E27FC236}">
+                <a16:creationId xmlns:a16="http://schemas.microsoft.com/office/drawing/2014/main" id="{479B4A78-7E60-1511-BF2A-ADEEA21116C0}"/>
+              </a:ext>
+            </a:extLst>
+          </p:cNvPr>
           <p:cNvSpPr/>
           <p:nvPr/>
         </p:nvSpPr>
@@ -1378,7 +1460,13 @@
       </p:sp>
       <p:sp>
         <p:nvSpPr>
-          <p:cNvPr id="7" name="Text 5"/>
+          <p:cNvPr id="7" name="Text 5">
+            <a:extLst>
+              <a:ext uri="{FF2B5EF4-FFF2-40B4-BE49-F238E27FC236}">
+                <a16:creationId xmlns:a16="http://schemas.microsoft.com/office/drawing/2014/main" id="{B61FA941-7F0F-B492-9C61-FC5CF3416A2B}"/>
+              </a:ext>
+            </a:extLst>
+          </p:cNvPr>
           <p:cNvSpPr/>
           <p:nvPr/>
         </p:nvSpPr>
@@ -1416,6 +1504,11 @@
         </p:txBody>
       </p:sp>
     </p:spTree>
+    <p:extLst>
+      <p:ext uri="{BB962C8B-B14F-4D97-AF65-F5344CB8AC3E}">
+        <p14:creationId xmlns:p14="http://schemas.microsoft.com/office/powerpoint/2010/main" val="2325281349"/>
+      </p:ext>
+    </p:extLst>
   </p:cSld>
   <p:clrMapOvr>
     <a:masterClrMapping/>
@@ -1526,831 +1619,915 @@
           </a:p>
         </p:txBody>
       </p:sp>
-      <p:sp>
-        <p:nvSpPr>
-          <p:cNvPr id="4" name="Shape 2"/>
-          <p:cNvSpPr/>
-          <p:nvPr/>
-        </p:nvSpPr>
-        <p:spPr>
-          <a:xfrm>
-            <a:off x="475488" y="1712239"/>
+      <p:grpSp>
+        <p:nvGrpSpPr>
+          <p:cNvPr id="31" name="Group 30">
+            <a:extLst>
+              <a:ext uri="{FF2B5EF4-FFF2-40B4-BE49-F238E27FC236}">
+                <a16:creationId xmlns:a16="http://schemas.microsoft.com/office/drawing/2014/main" id="{D5F74128-7A57-8308-18AA-1F37893EC3A2}"/>
+              </a:ext>
+            </a:extLst>
+          </p:cNvPr>
+          <p:cNvGrpSpPr/>
+          <p:nvPr/>
+        </p:nvGrpSpPr>
+        <p:grpSpPr>
+          <a:xfrm>
+            <a:off x="475488" y="1709771"/>
             <a:ext cx="1965960" cy="1298448"/>
-          </a:xfrm>
-          <a:prstGeom prst="rect">
-            <a:avLst/>
-          </a:prstGeom>
-          <a:solidFill>
-            <a:srgbClr val="FFFFFF"/>
-          </a:solidFill>
-          <a:ln w="12700">
+            <a:chOff x="475488" y="1712239"/>
+            <a:chExt cx="1965960" cy="1298448"/>
+          </a:xfrm>
+        </p:grpSpPr>
+        <p:sp>
+          <p:nvSpPr>
+            <p:cNvPr id="4" name="Shape 2"/>
+            <p:cNvSpPr/>
+            <p:nvPr/>
+          </p:nvSpPr>
+          <p:spPr>
+            <a:xfrm>
+              <a:off x="475488" y="1712239"/>
+              <a:ext cx="1965960" cy="1298448"/>
+            </a:xfrm>
+            <a:prstGeom prst="rect">
+              <a:avLst/>
+            </a:prstGeom>
             <a:solidFill>
-              <a:srgbClr val="CBD5E1"/>
+              <a:srgbClr val="FFFFFF"/>
             </a:solidFill>
-            <a:prstDash val="solid"/>
-          </a:ln>
-          <a:effectLst>
-            <a:outerShdw blurRad="101600" dist="38100" dir="8100000" algn="bl" rotWithShape="0">
-              <a:srgbClr val="000000">
-                <a:alpha val="10000"/>
-              </a:srgbClr>
-            </a:outerShdw>
-          </a:effectLst>
-        </p:spPr>
-        <p:txBody>
-          <a:bodyPr/>
-          <a:lstStyle/>
-          <a:p>
-            <a:endParaRPr lang="en-DE"/>
-          </a:p>
-        </p:txBody>
-      </p:sp>
-      <p:sp>
-        <p:nvSpPr>
-          <p:cNvPr id="5" name="Shape 3"/>
-          <p:cNvSpPr/>
-          <p:nvPr/>
-        </p:nvSpPr>
-        <p:spPr>
-          <a:xfrm>
-            <a:off x="475488" y="1712239"/>
-            <a:ext cx="1965960" cy="73152"/>
-          </a:xfrm>
-          <a:prstGeom prst="rect">
-            <a:avLst/>
-          </a:prstGeom>
-          <a:solidFill>
-            <a:srgbClr val="B23A48"/>
-          </a:solidFill>
-          <a:ln w="12700">
+            <a:ln w="12700">
+              <a:solidFill>
+                <a:srgbClr val="CBD5E1"/>
+              </a:solidFill>
+              <a:prstDash val="solid"/>
+            </a:ln>
+            <a:effectLst>
+              <a:outerShdw blurRad="101600" dist="38100" dir="8100000" algn="bl" rotWithShape="0">
+                <a:srgbClr val="000000">
+                  <a:alpha val="10000"/>
+                </a:srgbClr>
+              </a:outerShdw>
+            </a:effectLst>
+          </p:spPr>
+          <p:txBody>
+            <a:bodyPr/>
+            <a:lstStyle/>
+            <a:p>
+              <a:endParaRPr lang="en-DE"/>
+            </a:p>
+          </p:txBody>
+        </p:sp>
+        <p:sp>
+          <p:nvSpPr>
+            <p:cNvPr id="5" name="Shape 3"/>
+            <p:cNvSpPr/>
+            <p:nvPr/>
+          </p:nvSpPr>
+          <p:spPr>
+            <a:xfrm>
+              <a:off x="475488" y="1712239"/>
+              <a:ext cx="1965960" cy="73152"/>
+            </a:xfrm>
+            <a:prstGeom prst="rect">
+              <a:avLst/>
+            </a:prstGeom>
             <a:solidFill>
               <a:srgbClr val="B23A48"/>
             </a:solidFill>
-            <a:prstDash val="solid"/>
-          </a:ln>
-        </p:spPr>
-        <p:txBody>
-          <a:bodyPr/>
-          <a:lstStyle/>
-          <a:p>
-            <a:endParaRPr lang="en-DE"/>
-          </a:p>
-        </p:txBody>
-      </p:sp>
-      <p:sp>
-        <p:nvSpPr>
-          <p:cNvPr id="6" name="Text 4"/>
-          <p:cNvSpPr/>
-          <p:nvPr/>
-        </p:nvSpPr>
-        <p:spPr>
-          <a:xfrm>
-            <a:off x="612648" y="1849399"/>
-            <a:ext cx="1737360" cy="256032"/>
-          </a:xfrm>
-          <a:prstGeom prst="rect">
-            <a:avLst/>
-          </a:prstGeom>
-          <a:noFill/>
-          <a:ln/>
-        </p:spPr>
-        <p:txBody>
-          <a:bodyPr wrap="square" lIns="0" tIns="0" rIns="0" bIns="0" rtlCol="0" anchor="ctr"/>
-          <a:lstStyle/>
-          <a:p>
-            <a:pPr marL="0" indent="0" algn="l">
-              <a:buNone/>
-            </a:pPr>
-            <a:r>
-              <a:rPr lang="en-US" sz="700" b="1" kern="0" spc="200" dirty="0">
-                <a:solidFill>
-                  <a:srgbClr val="64748B"/>
-                </a:solidFill>
-                <a:latin typeface="Calibri" pitchFamily="34" charset="0"/>
-                <a:ea typeface="Calibri" pitchFamily="34" charset="-122"/>
-                <a:cs typeface="Calibri" pitchFamily="34" charset="-120"/>
-              </a:rPr>
-              <a:t>LIFETIME LOST ARR</a:t>
-            </a:r>
-            <a:endParaRPr lang="en-US" sz="700" dirty="0"/>
-          </a:p>
-        </p:txBody>
-      </p:sp>
-      <p:sp>
-        <p:nvSpPr>
-          <p:cNvPr id="7" name="Text 5"/>
-          <p:cNvSpPr/>
-          <p:nvPr/>
-        </p:nvSpPr>
-        <p:spPr>
-          <a:xfrm>
-            <a:off x="585216" y="2096287"/>
-            <a:ext cx="1783080" cy="594360"/>
-          </a:xfrm>
-          <a:prstGeom prst="rect">
-            <a:avLst/>
-          </a:prstGeom>
-          <a:noFill/>
-          <a:ln/>
-        </p:spPr>
-        <p:txBody>
-          <a:bodyPr wrap="square" lIns="0" tIns="0" rIns="0" bIns="0" rtlCol="0" anchor="ctr"/>
-          <a:lstStyle/>
-          <a:p>
-            <a:pPr marL="0" indent="0" algn="l">
-              <a:buNone/>
-            </a:pPr>
-            <a:r>
-              <a:rPr lang="en-US" sz="3600" b="1" dirty="0">
-                <a:solidFill>
-                  <a:srgbClr val="B23A48"/>
-                </a:solidFill>
-                <a:latin typeface="Cambria" pitchFamily="34" charset="0"/>
-                <a:ea typeface="Cambria" pitchFamily="34" charset="-122"/>
-                <a:cs typeface="Cambria" pitchFamily="34" charset="-120"/>
-              </a:rPr>
-              <a:t>$14.1M</a:t>
-            </a:r>
-            <a:endParaRPr lang="en-US" sz="3600" dirty="0"/>
-          </a:p>
-        </p:txBody>
-      </p:sp>
-      <p:sp>
-        <p:nvSpPr>
-          <p:cNvPr id="8" name="Text 6"/>
-          <p:cNvSpPr/>
-          <p:nvPr/>
-        </p:nvSpPr>
-        <p:spPr>
-          <a:xfrm>
-            <a:off x="612648" y="2672359"/>
-            <a:ext cx="1737360" cy="320040"/>
-          </a:xfrm>
-          <a:prstGeom prst="rect">
-            <a:avLst/>
-          </a:prstGeom>
-          <a:noFill/>
-          <a:ln/>
-        </p:spPr>
-        <p:txBody>
-          <a:bodyPr wrap="square" lIns="0" tIns="0" rIns="0" bIns="0" rtlCol="0" anchor="ctr"/>
-          <a:lstStyle/>
-          <a:p>
-            <a:pPr marL="0" indent="0" algn="l">
-              <a:buNone/>
-            </a:pPr>
-            <a:r>
-              <a:rPr lang="en-US" sz="900" dirty="0">
-                <a:solidFill>
-                  <a:srgbClr val="64748B"/>
-                </a:solidFill>
-                <a:latin typeface="Calibri" pitchFamily="34" charset="0"/>
-                <a:ea typeface="Calibri" pitchFamily="34" charset="-122"/>
-                <a:cs typeface="Calibri" pitchFamily="34" charset="-120"/>
-              </a:rPr>
-              <a:t>From cancelled subscriptions,</a:t>
-            </a:r>
-            <a:endParaRPr lang="en-US" sz="900" dirty="0"/>
-          </a:p>
-          <a:p>
-            <a:pPr marL="0" indent="0" algn="l">
-              <a:buNone/>
-            </a:pPr>
-            <a:r>
-              <a:rPr lang="en-US" sz="900" dirty="0">
-                <a:solidFill>
-                  <a:srgbClr val="64748B"/>
-                </a:solidFill>
-                <a:latin typeface="Calibri" pitchFamily="34" charset="0"/>
-                <a:ea typeface="Calibri" pitchFamily="34" charset="-122"/>
-                <a:cs typeface="Calibri" pitchFamily="34" charset="-120"/>
-              </a:rPr>
-              <a:t>2023 to 2024.</a:t>
-            </a:r>
-            <a:endParaRPr lang="en-US" sz="900" dirty="0"/>
-          </a:p>
-        </p:txBody>
-      </p:sp>
-      <p:sp>
-        <p:nvSpPr>
-          <p:cNvPr id="9" name="Shape 7"/>
-          <p:cNvSpPr/>
-          <p:nvPr/>
-        </p:nvSpPr>
-        <p:spPr>
-          <a:xfrm>
-            <a:off x="2642616" y="1712239"/>
+            <a:ln w="12700">
+              <a:solidFill>
+                <a:srgbClr val="B23A48"/>
+              </a:solidFill>
+              <a:prstDash val="solid"/>
+            </a:ln>
+          </p:spPr>
+          <p:txBody>
+            <a:bodyPr/>
+            <a:lstStyle/>
+            <a:p>
+              <a:endParaRPr lang="en-DE"/>
+            </a:p>
+          </p:txBody>
+        </p:sp>
+        <p:sp>
+          <p:nvSpPr>
+            <p:cNvPr id="6" name="Text 4"/>
+            <p:cNvSpPr/>
+            <p:nvPr/>
+          </p:nvSpPr>
+          <p:spPr>
+            <a:xfrm>
+              <a:off x="612648" y="1849399"/>
+              <a:ext cx="1737360" cy="256032"/>
+            </a:xfrm>
+            <a:prstGeom prst="rect">
+              <a:avLst/>
+            </a:prstGeom>
+            <a:noFill/>
+            <a:ln/>
+          </p:spPr>
+          <p:txBody>
+            <a:bodyPr wrap="square" lIns="0" tIns="0" rIns="0" bIns="0" rtlCol="0" anchor="ctr"/>
+            <a:lstStyle/>
+            <a:p>
+              <a:pPr marL="0" indent="0" algn="l">
+                <a:buNone/>
+              </a:pPr>
+              <a:r>
+                <a:rPr lang="en-US" sz="700" b="1" kern="0" spc="200" dirty="0">
+                  <a:solidFill>
+                    <a:srgbClr val="64748B"/>
+                  </a:solidFill>
+                  <a:latin typeface="Calibri" pitchFamily="34" charset="0"/>
+                  <a:ea typeface="Calibri" pitchFamily="34" charset="-122"/>
+                  <a:cs typeface="Calibri" pitchFamily="34" charset="-120"/>
+                </a:rPr>
+                <a:t>LIFETIME LOST ARR</a:t>
+              </a:r>
+              <a:endParaRPr lang="en-US" sz="700" dirty="0"/>
+            </a:p>
+          </p:txBody>
+        </p:sp>
+        <p:sp>
+          <p:nvSpPr>
+            <p:cNvPr id="7" name="Text 5"/>
+            <p:cNvSpPr/>
+            <p:nvPr/>
+          </p:nvSpPr>
+          <p:spPr>
+            <a:xfrm>
+              <a:off x="585216" y="2096287"/>
+              <a:ext cx="1783080" cy="594360"/>
+            </a:xfrm>
+            <a:prstGeom prst="rect">
+              <a:avLst/>
+            </a:prstGeom>
+            <a:noFill/>
+            <a:ln/>
+          </p:spPr>
+          <p:txBody>
+            <a:bodyPr wrap="square" lIns="0" tIns="0" rIns="0" bIns="0" rtlCol="0" anchor="ctr"/>
+            <a:lstStyle/>
+            <a:p>
+              <a:pPr marL="0" indent="0" algn="l">
+                <a:buNone/>
+              </a:pPr>
+              <a:r>
+                <a:rPr lang="en-US" sz="3600" b="1" dirty="0">
+                  <a:solidFill>
+                    <a:srgbClr val="B23A48"/>
+                  </a:solidFill>
+                  <a:latin typeface="Cambria" pitchFamily="34" charset="0"/>
+                  <a:ea typeface="Cambria" pitchFamily="34" charset="-122"/>
+                  <a:cs typeface="Cambria" pitchFamily="34" charset="-120"/>
+                </a:rPr>
+                <a:t>$14.1M</a:t>
+              </a:r>
+              <a:endParaRPr lang="en-US" sz="3600" dirty="0"/>
+            </a:p>
+          </p:txBody>
+        </p:sp>
+        <p:sp>
+          <p:nvSpPr>
+            <p:cNvPr id="8" name="Text 6"/>
+            <p:cNvSpPr/>
+            <p:nvPr/>
+          </p:nvSpPr>
+          <p:spPr>
+            <a:xfrm>
+              <a:off x="612648" y="2672359"/>
+              <a:ext cx="1737360" cy="320040"/>
+            </a:xfrm>
+            <a:prstGeom prst="rect">
+              <a:avLst/>
+            </a:prstGeom>
+            <a:noFill/>
+            <a:ln/>
+          </p:spPr>
+          <p:txBody>
+            <a:bodyPr wrap="square" lIns="0" tIns="0" rIns="0" bIns="0" rtlCol="0" anchor="ctr"/>
+            <a:lstStyle/>
+            <a:p>
+              <a:pPr marL="0" indent="0" algn="l">
+                <a:buNone/>
+              </a:pPr>
+              <a:r>
+                <a:rPr lang="en-US" sz="900" dirty="0">
+                  <a:solidFill>
+                    <a:srgbClr val="64748B"/>
+                  </a:solidFill>
+                  <a:latin typeface="Calibri" pitchFamily="34" charset="0"/>
+                  <a:ea typeface="Calibri" pitchFamily="34" charset="-122"/>
+                  <a:cs typeface="Calibri" pitchFamily="34" charset="-120"/>
+                </a:rPr>
+                <a:t>From cancelled subscriptions,</a:t>
+              </a:r>
+              <a:endParaRPr lang="en-US" sz="900" dirty="0"/>
+            </a:p>
+            <a:p>
+              <a:pPr marL="0" indent="0" algn="l">
+                <a:buNone/>
+              </a:pPr>
+              <a:r>
+                <a:rPr lang="en-US" sz="900" dirty="0">
+                  <a:solidFill>
+                    <a:srgbClr val="64748B"/>
+                  </a:solidFill>
+                  <a:latin typeface="Calibri" pitchFamily="34" charset="0"/>
+                  <a:ea typeface="Calibri" pitchFamily="34" charset="-122"/>
+                  <a:cs typeface="Calibri" pitchFamily="34" charset="-120"/>
+                </a:rPr>
+                <a:t>2023 to 2024.</a:t>
+              </a:r>
+              <a:endParaRPr lang="en-US" sz="900" dirty="0"/>
+            </a:p>
+          </p:txBody>
+        </p:sp>
+      </p:grpSp>
+      <p:grpSp>
+        <p:nvGrpSpPr>
+          <p:cNvPr id="26" name="Group 25">
+            <a:extLst>
+              <a:ext uri="{FF2B5EF4-FFF2-40B4-BE49-F238E27FC236}">
+                <a16:creationId xmlns:a16="http://schemas.microsoft.com/office/drawing/2014/main" id="{E3AC74B9-ABAF-E69C-3A9B-71C01E8178A2}"/>
+              </a:ext>
+            </a:extLst>
+          </p:cNvPr>
+          <p:cNvGrpSpPr/>
+          <p:nvPr/>
+        </p:nvGrpSpPr>
+        <p:grpSpPr>
+          <a:xfrm>
+            <a:off x="6988168" y="1709771"/>
             <a:ext cx="1965960" cy="1298448"/>
-          </a:xfrm>
-          <a:prstGeom prst="rect">
-            <a:avLst/>
-          </a:prstGeom>
-          <a:solidFill>
-            <a:srgbClr val="FFFFFF"/>
-          </a:solidFill>
-          <a:ln w="12700">
+            <a:chOff x="2642616" y="1712239"/>
+            <a:chExt cx="1965960" cy="1298448"/>
+          </a:xfrm>
+        </p:grpSpPr>
+        <p:sp>
+          <p:nvSpPr>
+            <p:cNvPr id="9" name="Shape 7"/>
+            <p:cNvSpPr/>
+            <p:nvPr/>
+          </p:nvSpPr>
+          <p:spPr>
+            <a:xfrm>
+              <a:off x="2642616" y="1712239"/>
+              <a:ext cx="1965960" cy="1298448"/>
+            </a:xfrm>
+            <a:prstGeom prst="rect">
+              <a:avLst/>
+            </a:prstGeom>
+            <a:solidFill>
+              <a:srgbClr val="FFFFFF"/>
+            </a:solidFill>
+            <a:ln w="12700">
+              <a:solidFill>
+                <a:schemeClr val="accent6"/>
+              </a:solidFill>
+              <a:prstDash val="solid"/>
+            </a:ln>
+            <a:effectLst>
+              <a:outerShdw blurRad="101600" dist="38100" dir="8100000" algn="bl" rotWithShape="0">
+                <a:srgbClr val="000000">
+                  <a:alpha val="10000"/>
+                </a:srgbClr>
+              </a:outerShdw>
+            </a:effectLst>
+          </p:spPr>
+          <p:txBody>
+            <a:bodyPr/>
+            <a:lstStyle/>
+            <a:p>
+              <a:endParaRPr lang="en-DE"/>
+            </a:p>
+          </p:txBody>
+        </p:sp>
+        <p:sp>
+          <p:nvSpPr>
+            <p:cNvPr id="10" name="Shape 8"/>
+            <p:cNvSpPr/>
+            <p:nvPr/>
+          </p:nvSpPr>
+          <p:spPr>
+            <a:xfrm>
+              <a:off x="2642616" y="1712239"/>
+              <a:ext cx="1965960" cy="73152"/>
+            </a:xfrm>
+            <a:prstGeom prst="rect">
+              <a:avLst/>
+            </a:prstGeom>
             <a:solidFill>
               <a:schemeClr val="accent6"/>
             </a:solidFill>
-            <a:prstDash val="solid"/>
-          </a:ln>
-          <a:effectLst>
-            <a:outerShdw blurRad="101600" dist="38100" dir="8100000" algn="bl" rotWithShape="0">
-              <a:srgbClr val="000000">
-                <a:alpha val="10000"/>
-              </a:srgbClr>
-            </a:outerShdw>
-          </a:effectLst>
-        </p:spPr>
-        <p:txBody>
-          <a:bodyPr/>
-          <a:lstStyle/>
-          <a:p>
-            <a:endParaRPr lang="en-DE"/>
-          </a:p>
-        </p:txBody>
-      </p:sp>
-      <p:sp>
-        <p:nvSpPr>
-          <p:cNvPr id="10" name="Shape 8"/>
-          <p:cNvSpPr/>
-          <p:nvPr/>
-        </p:nvSpPr>
-        <p:spPr>
-          <a:xfrm>
-            <a:off x="2642616" y="1712239"/>
-            <a:ext cx="1965960" cy="73152"/>
-          </a:xfrm>
-          <a:prstGeom prst="rect">
-            <a:avLst/>
-          </a:prstGeom>
-          <a:solidFill>
-            <a:schemeClr val="accent6"/>
-          </a:solidFill>
-          <a:ln w="12700">
-            <a:solidFill>
-              <a:schemeClr val="accent6"/>
-            </a:solidFill>
-            <a:prstDash val="solid"/>
-          </a:ln>
-        </p:spPr>
-        <p:txBody>
-          <a:bodyPr/>
-          <a:lstStyle/>
-          <a:p>
-            <a:endParaRPr lang="en-DE" dirty="0"/>
-          </a:p>
-        </p:txBody>
-      </p:sp>
-      <p:sp>
-        <p:nvSpPr>
-          <p:cNvPr id="11" name="Text 9"/>
-          <p:cNvSpPr/>
-          <p:nvPr/>
-        </p:nvSpPr>
-        <p:spPr>
-          <a:xfrm>
-            <a:off x="2779776" y="1849399"/>
-            <a:ext cx="1737360" cy="256032"/>
-          </a:xfrm>
-          <a:prstGeom prst="rect">
-            <a:avLst/>
-          </a:prstGeom>
-          <a:noFill/>
-          <a:ln/>
-        </p:spPr>
-        <p:txBody>
-          <a:bodyPr wrap="square" lIns="0" tIns="0" rIns="0" bIns="0" rtlCol="0" anchor="ctr"/>
-          <a:lstStyle/>
-          <a:p>
-            <a:pPr marL="0" indent="0" algn="l">
-              <a:buNone/>
-            </a:pPr>
-            <a:r>
-              <a:rPr lang="en-US" sz="700" b="1" kern="0" spc="200" dirty="0">
-                <a:solidFill>
-                  <a:srgbClr val="64748B"/>
-                </a:solidFill>
-                <a:latin typeface="Calibri" pitchFamily="34" charset="0"/>
-                <a:ea typeface="Calibri" pitchFamily="34" charset="-122"/>
-                <a:cs typeface="Calibri" pitchFamily="34" charset="-120"/>
-              </a:rPr>
-              <a:t>BEST IN CLASS CHURN RATE</a:t>
-            </a:r>
-            <a:endParaRPr lang="en-US" sz="700" dirty="0"/>
-          </a:p>
-        </p:txBody>
-      </p:sp>
-      <p:sp>
-        <p:nvSpPr>
-          <p:cNvPr id="12" name="Text 10"/>
-          <p:cNvSpPr/>
-          <p:nvPr/>
-        </p:nvSpPr>
-        <p:spPr>
-          <a:xfrm>
-            <a:off x="2752344" y="2096287"/>
-            <a:ext cx="1783080" cy="594360"/>
-          </a:xfrm>
-          <a:prstGeom prst="rect">
-            <a:avLst/>
-          </a:prstGeom>
-          <a:noFill/>
-          <a:ln/>
-        </p:spPr>
-        <p:txBody>
-          <a:bodyPr wrap="square" lIns="0" tIns="0" rIns="0" bIns="0" rtlCol="0" anchor="ctr"/>
-          <a:lstStyle/>
-          <a:p>
-            <a:r>
-              <a:rPr lang="en-US" sz="3600" b="1" dirty="0">
-                <a:solidFill>
-                  <a:schemeClr val="accent6"/>
-                </a:solidFill>
-                <a:latin typeface="Cambria" pitchFamily="34" charset="0"/>
-                <a:ea typeface="Cambria" pitchFamily="34" charset="-122"/>
-                <a:cs typeface="Cambria" pitchFamily="34" charset="-120"/>
-              </a:rPr>
-              <a:t>&lt; 10 %</a:t>
-            </a:r>
-            <a:endParaRPr lang="en-US" sz="3600" dirty="0">
+            <a:ln w="12700">
               <a:solidFill>
                 <a:schemeClr val="accent6"/>
               </a:solidFill>
-            </a:endParaRPr>
-          </a:p>
-        </p:txBody>
-      </p:sp>
-      <p:sp>
-        <p:nvSpPr>
-          <p:cNvPr id="13" name="Text 11"/>
-          <p:cNvSpPr/>
-          <p:nvPr/>
-        </p:nvSpPr>
-        <p:spPr>
-          <a:xfrm>
-            <a:off x="2779776" y="2672359"/>
-            <a:ext cx="1737360" cy="320040"/>
-          </a:xfrm>
-          <a:prstGeom prst="rect">
-            <a:avLst/>
-          </a:prstGeom>
-          <a:noFill/>
-          <a:ln/>
-        </p:spPr>
-        <p:txBody>
-          <a:bodyPr wrap="square" lIns="0" tIns="0" rIns="0" bIns="0" rtlCol="0" anchor="ctr"/>
-          <a:lstStyle/>
-          <a:p>
-            <a:pPr marL="0" indent="0" algn="l">
-              <a:buNone/>
-            </a:pPr>
-            <a:r>
-              <a:rPr lang="en-US" sz="900" dirty="0">
-                <a:solidFill>
-                  <a:srgbClr val="64748B"/>
-                </a:solidFill>
-                <a:latin typeface="Calibri" pitchFamily="34" charset="0"/>
-                <a:ea typeface="Calibri" pitchFamily="34" charset="-122"/>
-                <a:cs typeface="Calibri" pitchFamily="34" charset="-120"/>
-              </a:rPr>
-              <a:t>SMB benchmark </a:t>
-            </a:r>
-            <a:br>
-              <a:rPr lang="en-US" sz="900" dirty="0">
-                <a:solidFill>
-                  <a:srgbClr val="64748B"/>
-                </a:solidFill>
-                <a:latin typeface="Calibri" pitchFamily="34" charset="0"/>
-                <a:ea typeface="Calibri" pitchFamily="34" charset="-122"/>
-                <a:cs typeface="Calibri" pitchFamily="34" charset="-120"/>
-              </a:rPr>
-            </a:br>
-            <a:r>
-              <a:rPr lang="en-US" sz="900" dirty="0">
-                <a:solidFill>
-                  <a:srgbClr val="64748B"/>
-                </a:solidFill>
-                <a:latin typeface="Calibri" pitchFamily="34" charset="0"/>
-                <a:ea typeface="Calibri" pitchFamily="34" charset="-122"/>
-                <a:cs typeface="Calibri" pitchFamily="34" charset="-120"/>
-              </a:rPr>
-              <a:t>on active ARR.</a:t>
-            </a:r>
-            <a:endParaRPr lang="en-US" sz="900" dirty="0"/>
-          </a:p>
-        </p:txBody>
-      </p:sp>
-      <p:sp>
-        <p:nvSpPr>
-          <p:cNvPr id="14" name="Shape 12"/>
-          <p:cNvSpPr/>
-          <p:nvPr/>
-        </p:nvSpPr>
-        <p:spPr>
-          <a:xfrm>
-            <a:off x="4809744" y="1712239"/>
+              <a:prstDash val="solid"/>
+            </a:ln>
+          </p:spPr>
+          <p:txBody>
+            <a:bodyPr/>
+            <a:lstStyle/>
+            <a:p>
+              <a:endParaRPr lang="en-DE" dirty="0"/>
+            </a:p>
+          </p:txBody>
+        </p:sp>
+        <p:sp>
+          <p:nvSpPr>
+            <p:cNvPr id="11" name="Text 9"/>
+            <p:cNvSpPr/>
+            <p:nvPr/>
+          </p:nvSpPr>
+          <p:spPr>
+            <a:xfrm>
+              <a:off x="2779776" y="1849399"/>
+              <a:ext cx="1737360" cy="256032"/>
+            </a:xfrm>
+            <a:prstGeom prst="rect">
+              <a:avLst/>
+            </a:prstGeom>
+            <a:noFill/>
+            <a:ln/>
+          </p:spPr>
+          <p:txBody>
+            <a:bodyPr wrap="square" lIns="0" tIns="0" rIns="0" bIns="0" rtlCol="0" anchor="ctr"/>
+            <a:lstStyle/>
+            <a:p>
+              <a:pPr marL="0" indent="0" algn="l">
+                <a:buNone/>
+              </a:pPr>
+              <a:r>
+                <a:rPr lang="en-US" sz="700" b="1" kern="0" spc="200" dirty="0">
+                  <a:solidFill>
+                    <a:srgbClr val="64748B"/>
+                  </a:solidFill>
+                  <a:latin typeface="Calibri" pitchFamily="34" charset="0"/>
+                  <a:ea typeface="Calibri" pitchFamily="34" charset="-122"/>
+                  <a:cs typeface="Calibri" pitchFamily="34" charset="-120"/>
+                </a:rPr>
+                <a:t>BEST IN CLASS CHURN RATE</a:t>
+              </a:r>
+              <a:endParaRPr lang="en-US" sz="700" dirty="0"/>
+            </a:p>
+          </p:txBody>
+        </p:sp>
+        <p:sp>
+          <p:nvSpPr>
+            <p:cNvPr id="12" name="Text 10"/>
+            <p:cNvSpPr/>
+            <p:nvPr/>
+          </p:nvSpPr>
+          <p:spPr>
+            <a:xfrm>
+              <a:off x="2752344" y="2096287"/>
+              <a:ext cx="1783080" cy="594360"/>
+            </a:xfrm>
+            <a:prstGeom prst="rect">
+              <a:avLst/>
+            </a:prstGeom>
+            <a:noFill/>
+            <a:ln/>
+          </p:spPr>
+          <p:txBody>
+            <a:bodyPr wrap="square" lIns="0" tIns="0" rIns="0" bIns="0" rtlCol="0" anchor="ctr"/>
+            <a:lstStyle/>
+            <a:p>
+              <a:r>
+                <a:rPr lang="en-US" sz="3600" b="1" dirty="0">
+                  <a:solidFill>
+                    <a:schemeClr val="accent6"/>
+                  </a:solidFill>
+                  <a:latin typeface="Cambria" pitchFamily="34" charset="0"/>
+                  <a:ea typeface="Cambria" pitchFamily="34" charset="-122"/>
+                  <a:cs typeface="Cambria" pitchFamily="34" charset="-120"/>
+                </a:rPr>
+                <a:t>&lt; 10 %</a:t>
+              </a:r>
+              <a:endParaRPr lang="en-US" sz="3600" dirty="0">
+                <a:solidFill>
+                  <a:schemeClr val="accent6"/>
+                </a:solidFill>
+              </a:endParaRPr>
+            </a:p>
+          </p:txBody>
+        </p:sp>
+        <p:sp>
+          <p:nvSpPr>
+            <p:cNvPr id="13" name="Text 11"/>
+            <p:cNvSpPr/>
+            <p:nvPr/>
+          </p:nvSpPr>
+          <p:spPr>
+            <a:xfrm>
+              <a:off x="2779776" y="2672359"/>
+              <a:ext cx="1737360" cy="320040"/>
+            </a:xfrm>
+            <a:prstGeom prst="rect">
+              <a:avLst/>
+            </a:prstGeom>
+            <a:noFill/>
+            <a:ln/>
+          </p:spPr>
+          <p:txBody>
+            <a:bodyPr wrap="square" lIns="0" tIns="0" rIns="0" bIns="0" rtlCol="0" anchor="ctr"/>
+            <a:lstStyle/>
+            <a:p>
+              <a:pPr marL="0" indent="0" algn="l">
+                <a:buNone/>
+              </a:pPr>
+              <a:r>
+                <a:rPr lang="en-US" sz="900" dirty="0">
+                  <a:solidFill>
+                    <a:srgbClr val="64748B"/>
+                  </a:solidFill>
+                  <a:latin typeface="Calibri" pitchFamily="34" charset="0"/>
+                  <a:ea typeface="Calibri" pitchFamily="34" charset="-122"/>
+                  <a:cs typeface="Calibri" pitchFamily="34" charset="-120"/>
+                </a:rPr>
+                <a:t>SMB benchmark </a:t>
+              </a:r>
+              <a:br>
+                <a:rPr lang="en-US" sz="900" dirty="0">
+                  <a:solidFill>
+                    <a:srgbClr val="64748B"/>
+                  </a:solidFill>
+                  <a:latin typeface="Calibri" pitchFamily="34" charset="0"/>
+                  <a:ea typeface="Calibri" pitchFamily="34" charset="-122"/>
+                  <a:cs typeface="Calibri" pitchFamily="34" charset="-120"/>
+                </a:rPr>
+              </a:br>
+              <a:r>
+                <a:rPr lang="en-US" sz="900" dirty="0">
+                  <a:solidFill>
+                    <a:srgbClr val="64748B"/>
+                  </a:solidFill>
+                  <a:latin typeface="Calibri" pitchFamily="34" charset="0"/>
+                  <a:ea typeface="Calibri" pitchFamily="34" charset="-122"/>
+                  <a:cs typeface="Calibri" pitchFamily="34" charset="-120"/>
+                </a:rPr>
+                <a:t>on active ARR.</a:t>
+              </a:r>
+              <a:endParaRPr lang="en-US" sz="900" dirty="0"/>
+            </a:p>
+          </p:txBody>
+        </p:sp>
+      </p:grpSp>
+      <p:grpSp>
+        <p:nvGrpSpPr>
+          <p:cNvPr id="30" name="Group 29">
+            <a:extLst>
+              <a:ext uri="{FF2B5EF4-FFF2-40B4-BE49-F238E27FC236}">
+                <a16:creationId xmlns:a16="http://schemas.microsoft.com/office/drawing/2014/main" id="{A2E64B02-72FB-0E44-DCE8-15F1D5704F2F}"/>
+              </a:ext>
+            </a:extLst>
+          </p:cNvPr>
+          <p:cNvGrpSpPr/>
+          <p:nvPr/>
+        </p:nvGrpSpPr>
+        <p:grpSpPr>
+          <a:xfrm>
+            <a:off x="4817274" y="1709771"/>
             <a:ext cx="1965960" cy="1298448"/>
-          </a:xfrm>
-          <a:prstGeom prst="rect">
-            <a:avLst/>
-          </a:prstGeom>
-          <a:solidFill>
-            <a:srgbClr val="FFFFFF"/>
-          </a:solidFill>
-          <a:ln w="12700">
+            <a:chOff x="4809744" y="1712239"/>
+            <a:chExt cx="1965960" cy="1298448"/>
+          </a:xfrm>
+        </p:grpSpPr>
+        <p:sp>
+          <p:nvSpPr>
+            <p:cNvPr id="14" name="Shape 12"/>
+            <p:cNvSpPr/>
+            <p:nvPr/>
+          </p:nvSpPr>
+          <p:spPr>
+            <a:xfrm>
+              <a:off x="4809744" y="1712239"/>
+              <a:ext cx="1965960" cy="1298448"/>
+            </a:xfrm>
+            <a:prstGeom prst="rect">
+              <a:avLst/>
+            </a:prstGeom>
             <a:solidFill>
-              <a:srgbClr val="CBD5E1"/>
+              <a:srgbClr val="FFFFFF"/>
             </a:solidFill>
-            <a:prstDash val="solid"/>
-          </a:ln>
-          <a:effectLst>
-            <a:outerShdw blurRad="101600" dist="38100" dir="8100000" algn="bl" rotWithShape="0">
-              <a:srgbClr val="000000">
-                <a:alpha val="10000"/>
-              </a:srgbClr>
-            </a:outerShdw>
-          </a:effectLst>
-        </p:spPr>
-        <p:txBody>
-          <a:bodyPr/>
-          <a:lstStyle/>
-          <a:p>
-            <a:endParaRPr lang="en-DE"/>
-          </a:p>
-        </p:txBody>
-      </p:sp>
-      <p:sp>
-        <p:nvSpPr>
-          <p:cNvPr id="15" name="Shape 13"/>
-          <p:cNvSpPr/>
-          <p:nvPr/>
-        </p:nvSpPr>
-        <p:spPr>
-          <a:xfrm>
-            <a:off x="4809744" y="1712239"/>
-            <a:ext cx="1965960" cy="73152"/>
-          </a:xfrm>
-          <a:prstGeom prst="rect">
-            <a:avLst/>
-          </a:prstGeom>
-          <a:solidFill>
-            <a:srgbClr val="2E74B5"/>
-          </a:solidFill>
-          <a:ln w="12700">
+            <a:ln w="12700">
+              <a:solidFill>
+                <a:srgbClr val="CBD5E1"/>
+              </a:solidFill>
+              <a:prstDash val="solid"/>
+            </a:ln>
+            <a:effectLst>
+              <a:outerShdw blurRad="101600" dist="38100" dir="8100000" algn="bl" rotWithShape="0">
+                <a:srgbClr val="000000">
+                  <a:alpha val="10000"/>
+                </a:srgbClr>
+              </a:outerShdw>
+            </a:effectLst>
+          </p:spPr>
+          <p:txBody>
+            <a:bodyPr/>
+            <a:lstStyle/>
+            <a:p>
+              <a:endParaRPr lang="en-DE"/>
+            </a:p>
+          </p:txBody>
+        </p:sp>
+        <p:sp>
+          <p:nvSpPr>
+            <p:cNvPr id="15" name="Shape 13"/>
+            <p:cNvSpPr/>
+            <p:nvPr/>
+          </p:nvSpPr>
+          <p:spPr>
+            <a:xfrm>
+              <a:off x="4809744" y="1712239"/>
+              <a:ext cx="1965960" cy="73152"/>
+            </a:xfrm>
+            <a:prstGeom prst="rect">
+              <a:avLst/>
+            </a:prstGeom>
             <a:solidFill>
               <a:srgbClr val="2E74B5"/>
             </a:solidFill>
-            <a:prstDash val="solid"/>
-          </a:ln>
-        </p:spPr>
-        <p:txBody>
-          <a:bodyPr/>
-          <a:lstStyle/>
-          <a:p>
-            <a:endParaRPr lang="en-DE"/>
-          </a:p>
-        </p:txBody>
-      </p:sp>
-      <p:sp>
-        <p:nvSpPr>
-          <p:cNvPr id="16" name="Text 14"/>
-          <p:cNvSpPr/>
-          <p:nvPr/>
-        </p:nvSpPr>
-        <p:spPr>
-          <a:xfrm>
-            <a:off x="4946904" y="1849399"/>
-            <a:ext cx="1737360" cy="256032"/>
-          </a:xfrm>
-          <a:prstGeom prst="rect">
-            <a:avLst/>
-          </a:prstGeom>
-          <a:noFill/>
-          <a:ln/>
-        </p:spPr>
-        <p:txBody>
-          <a:bodyPr wrap="square" lIns="0" tIns="0" rIns="0" bIns="0" rtlCol="0" anchor="ctr"/>
-          <a:lstStyle/>
-          <a:p>
-            <a:pPr marL="0" indent="0" algn="l">
-              <a:buNone/>
-            </a:pPr>
-            <a:r>
-              <a:rPr lang="en-US" sz="700" b="1" kern="0" spc="200" dirty="0">
-                <a:solidFill>
-                  <a:srgbClr val="64748B"/>
-                </a:solidFill>
-                <a:latin typeface="Calibri" pitchFamily="34" charset="0"/>
-                <a:ea typeface="Calibri" pitchFamily="34" charset="-122"/>
-                <a:cs typeface="Calibri" pitchFamily="34" charset="-120"/>
-              </a:rPr>
-              <a:t>ANNUAL CHURN RATE</a:t>
-            </a:r>
-            <a:endParaRPr lang="en-US" sz="700" dirty="0"/>
-          </a:p>
-        </p:txBody>
-      </p:sp>
-      <p:sp>
-        <p:nvSpPr>
-          <p:cNvPr id="17" name="Text 15"/>
-          <p:cNvSpPr/>
-          <p:nvPr/>
-        </p:nvSpPr>
-        <p:spPr>
-          <a:xfrm>
-            <a:off x="4919472" y="2096287"/>
-            <a:ext cx="1783080" cy="594360"/>
-          </a:xfrm>
-          <a:prstGeom prst="rect">
-            <a:avLst/>
-          </a:prstGeom>
-          <a:noFill/>
-          <a:ln/>
-        </p:spPr>
-        <p:txBody>
-          <a:bodyPr wrap="square" lIns="0" tIns="0" rIns="0" bIns="0" rtlCol="0" anchor="ctr"/>
-          <a:lstStyle/>
-          <a:p>
-            <a:pPr marL="0" indent="0" algn="l">
-              <a:buNone/>
-            </a:pPr>
-            <a:r>
-              <a:rPr lang="en-US" sz="3600" b="1" dirty="0">
-                <a:solidFill>
-                  <a:srgbClr val="2E74B5"/>
-                </a:solidFill>
-                <a:latin typeface="Cambria" pitchFamily="34" charset="0"/>
-                <a:ea typeface="Cambria" pitchFamily="34" charset="-122"/>
-                <a:cs typeface="Cambria" pitchFamily="34" charset="-120"/>
-              </a:rPr>
-              <a:t>12.1%</a:t>
-            </a:r>
-            <a:endParaRPr lang="en-US" sz="3600" dirty="0"/>
-          </a:p>
-        </p:txBody>
-      </p:sp>
-      <p:sp>
-        <p:nvSpPr>
-          <p:cNvPr id="18" name="Text 16"/>
-          <p:cNvSpPr/>
-          <p:nvPr/>
-        </p:nvSpPr>
-        <p:spPr>
-          <a:xfrm>
-            <a:off x="4946904" y="2672359"/>
-            <a:ext cx="1737360" cy="320040"/>
-          </a:xfrm>
-          <a:prstGeom prst="rect">
-            <a:avLst/>
-          </a:prstGeom>
-          <a:noFill/>
-          <a:ln/>
-        </p:spPr>
-        <p:txBody>
-          <a:bodyPr wrap="square" lIns="0" tIns="0" rIns="0" bIns="0" rtlCol="0" anchor="ctr"/>
-          <a:lstStyle/>
-          <a:p>
-            <a:pPr marL="0" indent="0" algn="l">
-              <a:buNone/>
-            </a:pPr>
-            <a:r>
-              <a:rPr lang="en-US" sz="900" dirty="0">
-                <a:solidFill>
-                  <a:srgbClr val="64748B"/>
-                </a:solidFill>
-                <a:latin typeface="Calibri" pitchFamily="34" charset="0"/>
-                <a:ea typeface="Calibri" pitchFamily="34" charset="-122"/>
-                <a:cs typeface="Calibri" pitchFamily="34" charset="-120"/>
-              </a:rPr>
-              <a:t>Annualised from 22% lifetime</a:t>
-            </a:r>
-            <a:endParaRPr lang="en-US" sz="900" dirty="0"/>
-          </a:p>
-          <a:p>
-            <a:pPr marL="0" indent="0" algn="l">
-              <a:buNone/>
-            </a:pPr>
-            <a:r>
-              <a:rPr lang="en-US" sz="900" dirty="0">
-                <a:solidFill>
-                  <a:srgbClr val="64748B"/>
-                </a:solidFill>
-                <a:latin typeface="Calibri" pitchFamily="34" charset="0"/>
-                <a:ea typeface="Calibri" pitchFamily="34" charset="-122"/>
-                <a:cs typeface="Calibri" pitchFamily="34" charset="-120"/>
-              </a:rPr>
-              <a:t>cancellation over 2 years.</a:t>
-            </a:r>
-            <a:endParaRPr lang="en-US" sz="900" dirty="0"/>
-          </a:p>
-        </p:txBody>
-      </p:sp>
-      <p:sp>
-        <p:nvSpPr>
-          <p:cNvPr id="19" name="Shape 17"/>
-          <p:cNvSpPr/>
-          <p:nvPr/>
-        </p:nvSpPr>
-        <p:spPr>
-          <a:xfrm>
-            <a:off x="6976872" y="1712239"/>
+            <a:ln w="12700">
+              <a:solidFill>
+                <a:srgbClr val="2E74B5"/>
+              </a:solidFill>
+              <a:prstDash val="solid"/>
+            </a:ln>
+          </p:spPr>
+          <p:txBody>
+            <a:bodyPr/>
+            <a:lstStyle/>
+            <a:p>
+              <a:endParaRPr lang="en-DE"/>
+            </a:p>
+          </p:txBody>
+        </p:sp>
+        <p:sp>
+          <p:nvSpPr>
+            <p:cNvPr id="16" name="Text 14"/>
+            <p:cNvSpPr/>
+            <p:nvPr/>
+          </p:nvSpPr>
+          <p:spPr>
+            <a:xfrm>
+              <a:off x="4946904" y="1849399"/>
+              <a:ext cx="1737360" cy="256032"/>
+            </a:xfrm>
+            <a:prstGeom prst="rect">
+              <a:avLst/>
+            </a:prstGeom>
+            <a:noFill/>
+            <a:ln/>
+          </p:spPr>
+          <p:txBody>
+            <a:bodyPr wrap="square" lIns="0" tIns="0" rIns="0" bIns="0" rtlCol="0" anchor="ctr"/>
+            <a:lstStyle/>
+            <a:p>
+              <a:pPr marL="0" indent="0" algn="l">
+                <a:buNone/>
+              </a:pPr>
+              <a:r>
+                <a:rPr lang="en-US" sz="700" b="1" kern="0" spc="200" dirty="0">
+                  <a:solidFill>
+                    <a:srgbClr val="64748B"/>
+                  </a:solidFill>
+                  <a:latin typeface="Calibri" pitchFamily="34" charset="0"/>
+                  <a:ea typeface="Calibri" pitchFamily="34" charset="-122"/>
+                  <a:cs typeface="Calibri" pitchFamily="34" charset="-120"/>
+                </a:rPr>
+                <a:t>ANNUAL CHURN RATE</a:t>
+              </a:r>
+              <a:endParaRPr lang="en-US" sz="700" dirty="0"/>
+            </a:p>
+          </p:txBody>
+        </p:sp>
+        <p:sp>
+          <p:nvSpPr>
+            <p:cNvPr id="17" name="Text 15"/>
+            <p:cNvSpPr/>
+            <p:nvPr/>
+          </p:nvSpPr>
+          <p:spPr>
+            <a:xfrm>
+              <a:off x="4919472" y="2096287"/>
+              <a:ext cx="1783080" cy="594360"/>
+            </a:xfrm>
+            <a:prstGeom prst="rect">
+              <a:avLst/>
+            </a:prstGeom>
+            <a:noFill/>
+            <a:ln/>
+          </p:spPr>
+          <p:txBody>
+            <a:bodyPr wrap="square" lIns="0" tIns="0" rIns="0" bIns="0" rtlCol="0" anchor="ctr"/>
+            <a:lstStyle/>
+            <a:p>
+              <a:pPr marL="0" indent="0" algn="l">
+                <a:buNone/>
+              </a:pPr>
+              <a:r>
+                <a:rPr lang="en-US" sz="3600" b="1" dirty="0">
+                  <a:solidFill>
+                    <a:srgbClr val="2E74B5"/>
+                  </a:solidFill>
+                  <a:latin typeface="Cambria" pitchFamily="34" charset="0"/>
+                  <a:ea typeface="Cambria" pitchFamily="34" charset="-122"/>
+                  <a:cs typeface="Cambria" pitchFamily="34" charset="-120"/>
+                </a:rPr>
+                <a:t>12.1%</a:t>
+              </a:r>
+              <a:endParaRPr lang="en-US" sz="3600" dirty="0"/>
+            </a:p>
+          </p:txBody>
+        </p:sp>
+        <p:sp>
+          <p:nvSpPr>
+            <p:cNvPr id="18" name="Text 16"/>
+            <p:cNvSpPr/>
+            <p:nvPr/>
+          </p:nvSpPr>
+          <p:spPr>
+            <a:xfrm>
+              <a:off x="4946904" y="2672359"/>
+              <a:ext cx="1737360" cy="320040"/>
+            </a:xfrm>
+            <a:prstGeom prst="rect">
+              <a:avLst/>
+            </a:prstGeom>
+            <a:noFill/>
+            <a:ln/>
+          </p:spPr>
+          <p:txBody>
+            <a:bodyPr wrap="square" lIns="0" tIns="0" rIns="0" bIns="0" rtlCol="0" anchor="ctr"/>
+            <a:lstStyle/>
+            <a:p>
+              <a:pPr marL="0" indent="0" algn="l">
+                <a:buNone/>
+              </a:pPr>
+              <a:r>
+                <a:rPr lang="en-US" sz="900" dirty="0">
+                  <a:solidFill>
+                    <a:srgbClr val="64748B"/>
+                  </a:solidFill>
+                  <a:latin typeface="Calibri" pitchFamily="34" charset="0"/>
+                  <a:ea typeface="Calibri" pitchFamily="34" charset="-122"/>
+                  <a:cs typeface="Calibri" pitchFamily="34" charset="-120"/>
+                </a:rPr>
+                <a:t>Annualised from 22% lifetime</a:t>
+              </a:r>
+              <a:endParaRPr lang="en-US" sz="900" dirty="0"/>
+            </a:p>
+            <a:p>
+              <a:pPr marL="0" indent="0" algn="l">
+                <a:buNone/>
+              </a:pPr>
+              <a:r>
+                <a:rPr lang="en-US" sz="900" dirty="0">
+                  <a:solidFill>
+                    <a:srgbClr val="64748B"/>
+                  </a:solidFill>
+                  <a:latin typeface="Calibri" pitchFamily="34" charset="0"/>
+                  <a:ea typeface="Calibri" pitchFamily="34" charset="-122"/>
+                  <a:cs typeface="Calibri" pitchFamily="34" charset="-120"/>
+                </a:rPr>
+                <a:t>cancellation over 2 years.</a:t>
+              </a:r>
+              <a:endParaRPr lang="en-US" sz="900" dirty="0"/>
+            </a:p>
+          </p:txBody>
+        </p:sp>
+      </p:grpSp>
+      <p:grpSp>
+        <p:nvGrpSpPr>
+          <p:cNvPr id="27" name="Group 26">
+            <a:extLst>
+              <a:ext uri="{FF2B5EF4-FFF2-40B4-BE49-F238E27FC236}">
+                <a16:creationId xmlns:a16="http://schemas.microsoft.com/office/drawing/2014/main" id="{7EE00724-9BB4-9D40-2636-CB4BBA1C5660}"/>
+              </a:ext>
+            </a:extLst>
+          </p:cNvPr>
+          <p:cNvGrpSpPr/>
+          <p:nvPr/>
+        </p:nvGrpSpPr>
+        <p:grpSpPr>
+          <a:xfrm>
+            <a:off x="2646381" y="1709771"/>
             <a:ext cx="1965960" cy="1298448"/>
-          </a:xfrm>
-          <a:prstGeom prst="rect">
-            <a:avLst/>
-          </a:prstGeom>
-          <a:solidFill>
-            <a:srgbClr val="FFFFFF"/>
-          </a:solidFill>
-          <a:ln w="12700">
+            <a:chOff x="6976872" y="1712239"/>
+            <a:chExt cx="1965960" cy="1298448"/>
+          </a:xfrm>
+        </p:grpSpPr>
+        <p:sp>
+          <p:nvSpPr>
+            <p:cNvPr id="19" name="Shape 17"/>
+            <p:cNvSpPr/>
+            <p:nvPr/>
+          </p:nvSpPr>
+          <p:spPr>
+            <a:xfrm>
+              <a:off x="6976872" y="1712239"/>
+              <a:ext cx="1965960" cy="1298448"/>
+            </a:xfrm>
+            <a:prstGeom prst="rect">
+              <a:avLst/>
+            </a:prstGeom>
             <a:solidFill>
-              <a:srgbClr val="CBD5E1"/>
+              <a:srgbClr val="FFFFFF"/>
             </a:solidFill>
-            <a:prstDash val="solid"/>
-          </a:ln>
-          <a:effectLst>
-            <a:outerShdw blurRad="101600" dist="38100" dir="8100000" algn="bl" rotWithShape="0">
-              <a:srgbClr val="000000">
-                <a:alpha val="10000"/>
-              </a:srgbClr>
-            </a:outerShdw>
-          </a:effectLst>
-        </p:spPr>
-        <p:txBody>
-          <a:bodyPr/>
-          <a:lstStyle/>
-          <a:p>
-            <a:endParaRPr lang="en-DE"/>
-          </a:p>
-        </p:txBody>
-      </p:sp>
-      <p:sp>
-        <p:nvSpPr>
-          <p:cNvPr id="20" name="Shape 18"/>
-          <p:cNvSpPr/>
-          <p:nvPr/>
-        </p:nvSpPr>
-        <p:spPr>
-          <a:xfrm>
-            <a:off x="6976872" y="1712239"/>
-            <a:ext cx="1965960" cy="73152"/>
-          </a:xfrm>
-          <a:prstGeom prst="rect">
-            <a:avLst/>
-          </a:prstGeom>
-          <a:solidFill>
-            <a:srgbClr val="1E293B"/>
-          </a:solidFill>
-          <a:ln w="12700">
+            <a:ln w="12700">
+              <a:solidFill>
+                <a:srgbClr val="CBD5E1"/>
+              </a:solidFill>
+              <a:prstDash val="solid"/>
+            </a:ln>
+            <a:effectLst>
+              <a:outerShdw blurRad="101600" dist="38100" dir="8100000" algn="bl" rotWithShape="0">
+                <a:srgbClr val="000000">
+                  <a:alpha val="10000"/>
+                </a:srgbClr>
+              </a:outerShdw>
+            </a:effectLst>
+          </p:spPr>
+          <p:txBody>
+            <a:bodyPr/>
+            <a:lstStyle/>
+            <a:p>
+              <a:endParaRPr lang="en-DE"/>
+            </a:p>
+          </p:txBody>
+        </p:sp>
+        <p:sp>
+          <p:nvSpPr>
+            <p:cNvPr id="20" name="Shape 18"/>
+            <p:cNvSpPr/>
+            <p:nvPr/>
+          </p:nvSpPr>
+          <p:spPr>
+            <a:xfrm>
+              <a:off x="6976872" y="1712239"/>
+              <a:ext cx="1965960" cy="73152"/>
+            </a:xfrm>
+            <a:prstGeom prst="rect">
+              <a:avLst/>
+            </a:prstGeom>
             <a:solidFill>
               <a:srgbClr val="1E293B"/>
             </a:solidFill>
-            <a:prstDash val="solid"/>
-          </a:ln>
-        </p:spPr>
-        <p:txBody>
-          <a:bodyPr/>
-          <a:lstStyle/>
-          <a:p>
-            <a:endParaRPr lang="en-DE"/>
-          </a:p>
-        </p:txBody>
-      </p:sp>
-      <p:sp>
-        <p:nvSpPr>
-          <p:cNvPr id="21" name="Text 19"/>
-          <p:cNvSpPr/>
-          <p:nvPr/>
-        </p:nvSpPr>
-        <p:spPr>
-          <a:xfrm>
-            <a:off x="7114032" y="1849399"/>
-            <a:ext cx="1737360" cy="256032"/>
-          </a:xfrm>
-          <a:prstGeom prst="rect">
-            <a:avLst/>
-          </a:prstGeom>
-          <a:noFill/>
-          <a:ln/>
-        </p:spPr>
-        <p:txBody>
-          <a:bodyPr wrap="square" lIns="0" tIns="0" rIns="0" bIns="0" rtlCol="0" anchor="ctr"/>
-          <a:lstStyle/>
-          <a:p>
-            <a:pPr marL="0" indent="0" algn="l">
-              <a:buNone/>
-            </a:pPr>
-            <a:r>
-              <a:rPr lang="en-US" sz="700" b="1" kern="0" spc="200" dirty="0">
-                <a:solidFill>
-                  <a:srgbClr val="64748B"/>
-                </a:solidFill>
-                <a:latin typeface="Calibri" pitchFamily="34" charset="0"/>
-                <a:ea typeface="Calibri" pitchFamily="34" charset="-122"/>
-                <a:cs typeface="Calibri" pitchFamily="34" charset="-120"/>
-              </a:rPr>
-              <a:t>ACCOUNTS CHURNED</a:t>
-            </a:r>
-            <a:endParaRPr lang="en-US" sz="700" dirty="0"/>
-          </a:p>
-        </p:txBody>
-      </p:sp>
-      <p:sp>
-        <p:nvSpPr>
-          <p:cNvPr id="22" name="Text 20"/>
-          <p:cNvSpPr/>
-          <p:nvPr/>
-        </p:nvSpPr>
-        <p:spPr>
-          <a:xfrm>
-            <a:off x="7086600" y="2096287"/>
-            <a:ext cx="1783080" cy="594360"/>
-          </a:xfrm>
-          <a:prstGeom prst="rect">
-            <a:avLst/>
-          </a:prstGeom>
-          <a:noFill/>
-          <a:ln/>
-        </p:spPr>
-        <p:txBody>
-          <a:bodyPr wrap="square" lIns="0" tIns="0" rIns="0" bIns="0" rtlCol="0" anchor="ctr"/>
-          <a:lstStyle/>
-          <a:p>
-            <a:pPr marL="0" indent="0" algn="l">
-              <a:buNone/>
-            </a:pPr>
-            <a:r>
-              <a:rPr lang="en-US" sz="3600" b="1" dirty="0">
-                <a:solidFill>
-                  <a:srgbClr val="1E293B"/>
-                </a:solidFill>
-                <a:latin typeface="Cambria" pitchFamily="34" charset="0"/>
-                <a:ea typeface="Cambria" pitchFamily="34" charset="-122"/>
-                <a:cs typeface="Cambria" pitchFamily="34" charset="-120"/>
-              </a:rPr>
-              <a:t>110</a:t>
-            </a:r>
-            <a:endParaRPr lang="en-US" sz="3600" dirty="0"/>
-          </a:p>
-        </p:txBody>
-      </p:sp>
-      <p:sp>
-        <p:nvSpPr>
-          <p:cNvPr id="23" name="Text 21"/>
-          <p:cNvSpPr/>
-          <p:nvPr/>
-        </p:nvSpPr>
-        <p:spPr>
-          <a:xfrm>
-            <a:off x="7114032" y="2672359"/>
-            <a:ext cx="1737360" cy="320040"/>
-          </a:xfrm>
-          <a:prstGeom prst="rect">
-            <a:avLst/>
-          </a:prstGeom>
-          <a:noFill/>
-          <a:ln/>
-        </p:spPr>
-        <p:txBody>
-          <a:bodyPr wrap="square" lIns="0" tIns="0" rIns="0" bIns="0" rtlCol="0" anchor="ctr"/>
-          <a:lstStyle/>
-          <a:p>
-            <a:pPr marL="0" indent="0" algn="l">
-              <a:buNone/>
-            </a:pPr>
-            <a:r>
-              <a:rPr lang="en-US" sz="900" dirty="0">
-                <a:solidFill>
-                  <a:srgbClr val="64748B"/>
-                </a:solidFill>
-                <a:latin typeface="Calibri" pitchFamily="34" charset="0"/>
-                <a:ea typeface="Calibri" pitchFamily="34" charset="-122"/>
-                <a:cs typeface="Calibri" pitchFamily="34" charset="-120"/>
-              </a:rPr>
-              <a:t>Out of 500 customers.</a:t>
-            </a:r>
-            <a:endParaRPr lang="en-US" sz="900" dirty="0"/>
-          </a:p>
-          <a:p>
-            <a:pPr marL="0" indent="0" algn="l">
-              <a:buNone/>
-            </a:pPr>
-            <a:r>
-              <a:rPr lang="en-US" sz="900" dirty="0">
-                <a:solidFill>
-                  <a:srgbClr val="64748B"/>
-                </a:solidFill>
-                <a:latin typeface="Calibri" pitchFamily="34" charset="0"/>
-                <a:ea typeface="Calibri" pitchFamily="34" charset="-122"/>
-                <a:cs typeface="Calibri" pitchFamily="34" charset="-120"/>
-              </a:rPr>
-              <a:t>22% of the base has left.</a:t>
-            </a:r>
-            <a:endParaRPr lang="en-US" sz="900" dirty="0"/>
-          </a:p>
-        </p:txBody>
-      </p:sp>
+            <a:ln w="12700">
+              <a:solidFill>
+                <a:srgbClr val="1E293B"/>
+              </a:solidFill>
+              <a:prstDash val="solid"/>
+            </a:ln>
+          </p:spPr>
+          <p:txBody>
+            <a:bodyPr/>
+            <a:lstStyle/>
+            <a:p>
+              <a:endParaRPr lang="en-DE"/>
+            </a:p>
+          </p:txBody>
+        </p:sp>
+        <p:sp>
+          <p:nvSpPr>
+            <p:cNvPr id="21" name="Text 19"/>
+            <p:cNvSpPr/>
+            <p:nvPr/>
+          </p:nvSpPr>
+          <p:spPr>
+            <a:xfrm>
+              <a:off x="7114032" y="1849399"/>
+              <a:ext cx="1737360" cy="256032"/>
+            </a:xfrm>
+            <a:prstGeom prst="rect">
+              <a:avLst/>
+            </a:prstGeom>
+            <a:noFill/>
+            <a:ln/>
+          </p:spPr>
+          <p:txBody>
+            <a:bodyPr wrap="square" lIns="0" tIns="0" rIns="0" bIns="0" rtlCol="0" anchor="ctr"/>
+            <a:lstStyle/>
+            <a:p>
+              <a:pPr marL="0" indent="0" algn="l">
+                <a:buNone/>
+              </a:pPr>
+              <a:r>
+                <a:rPr lang="en-US" sz="700" b="1" kern="0" spc="200" dirty="0">
+                  <a:solidFill>
+                    <a:srgbClr val="64748B"/>
+                  </a:solidFill>
+                  <a:latin typeface="Calibri" pitchFamily="34" charset="0"/>
+                  <a:ea typeface="Calibri" pitchFamily="34" charset="-122"/>
+                  <a:cs typeface="Calibri" pitchFamily="34" charset="-120"/>
+                </a:rPr>
+                <a:t>ACCOUNTS CHURNED</a:t>
+              </a:r>
+              <a:endParaRPr lang="en-US" sz="700" dirty="0"/>
+            </a:p>
+          </p:txBody>
+        </p:sp>
+        <p:sp>
+          <p:nvSpPr>
+            <p:cNvPr id="22" name="Text 20"/>
+            <p:cNvSpPr/>
+            <p:nvPr/>
+          </p:nvSpPr>
+          <p:spPr>
+            <a:xfrm>
+              <a:off x="7086600" y="2096287"/>
+              <a:ext cx="1783080" cy="594360"/>
+            </a:xfrm>
+            <a:prstGeom prst="rect">
+              <a:avLst/>
+            </a:prstGeom>
+            <a:noFill/>
+            <a:ln/>
+          </p:spPr>
+          <p:txBody>
+            <a:bodyPr wrap="square" lIns="0" tIns="0" rIns="0" bIns="0" rtlCol="0" anchor="ctr"/>
+            <a:lstStyle/>
+            <a:p>
+              <a:pPr marL="0" indent="0" algn="l">
+                <a:buNone/>
+              </a:pPr>
+              <a:r>
+                <a:rPr lang="en-US" sz="3600" b="1" dirty="0">
+                  <a:solidFill>
+                    <a:srgbClr val="1E293B"/>
+                  </a:solidFill>
+                  <a:latin typeface="Cambria" pitchFamily="34" charset="0"/>
+                  <a:ea typeface="Cambria" pitchFamily="34" charset="-122"/>
+                  <a:cs typeface="Cambria" pitchFamily="34" charset="-120"/>
+                </a:rPr>
+                <a:t>110</a:t>
+              </a:r>
+              <a:endParaRPr lang="en-US" sz="3600" dirty="0"/>
+            </a:p>
+          </p:txBody>
+        </p:sp>
+        <p:sp>
+          <p:nvSpPr>
+            <p:cNvPr id="23" name="Text 21"/>
+            <p:cNvSpPr/>
+            <p:nvPr/>
+          </p:nvSpPr>
+          <p:spPr>
+            <a:xfrm>
+              <a:off x="7114032" y="2672359"/>
+              <a:ext cx="1737360" cy="320040"/>
+            </a:xfrm>
+            <a:prstGeom prst="rect">
+              <a:avLst/>
+            </a:prstGeom>
+            <a:noFill/>
+            <a:ln/>
+          </p:spPr>
+          <p:txBody>
+            <a:bodyPr wrap="square" lIns="0" tIns="0" rIns="0" bIns="0" rtlCol="0" anchor="ctr"/>
+            <a:lstStyle/>
+            <a:p>
+              <a:pPr marL="0" indent="0" algn="l">
+                <a:buNone/>
+              </a:pPr>
+              <a:r>
+                <a:rPr lang="en-US" sz="900" dirty="0">
+                  <a:solidFill>
+                    <a:srgbClr val="64748B"/>
+                  </a:solidFill>
+                  <a:latin typeface="Calibri" pitchFamily="34" charset="0"/>
+                  <a:ea typeface="Calibri" pitchFamily="34" charset="-122"/>
+                  <a:cs typeface="Calibri" pitchFamily="34" charset="-120"/>
+                </a:rPr>
+                <a:t>Out of 500 customers.</a:t>
+              </a:r>
+              <a:endParaRPr lang="en-US" sz="900" dirty="0"/>
+            </a:p>
+            <a:p>
+              <a:pPr marL="0" indent="0" algn="l">
+                <a:buNone/>
+              </a:pPr>
+              <a:r>
+                <a:rPr lang="en-US" sz="900" dirty="0">
+                  <a:solidFill>
+                    <a:srgbClr val="64748B"/>
+                  </a:solidFill>
+                  <a:latin typeface="Calibri" pitchFamily="34" charset="0"/>
+                  <a:ea typeface="Calibri" pitchFamily="34" charset="-122"/>
+                  <a:cs typeface="Calibri" pitchFamily="34" charset="-120"/>
+                </a:rPr>
+                <a:t>22% of the base has left.</a:t>
+              </a:r>
+              <a:endParaRPr lang="en-US" sz="900" dirty="0"/>
+            </a:p>
+          </p:txBody>
+        </p:sp>
+      </p:grpSp>
       <p:grpSp>
         <p:nvGrpSpPr>
           <p:cNvPr id="29" name="Group 28">
@@ -2545,6 +2722,261 @@
   <p:clrMapOvr>
     <a:masterClrMapping/>
   </p:clrMapOvr>
+  <p:timing>
+    <p:tnLst>
+      <p:par>
+        <p:cTn id="1" dur="indefinite" restart="never" nodeType="tmRoot">
+          <p:childTnLst>
+            <p:seq concurrent="1" nextAc="seek">
+              <p:cTn id="2" dur="indefinite" nodeType="mainSeq">
+                <p:childTnLst>
+                  <p:par>
+                    <p:cTn id="3" fill="hold">
+                      <p:stCondLst>
+                        <p:cond delay="indefinite"/>
+                      </p:stCondLst>
+                      <p:childTnLst>
+                        <p:par>
+                          <p:cTn id="4" fill="hold">
+                            <p:stCondLst>
+                              <p:cond delay="0"/>
+                            </p:stCondLst>
+                            <p:childTnLst>
+                              <p:par>
+                                <p:cTn id="5" presetID="1" presetClass="entr" presetSubtype="0" fill="hold" nodeType="clickEffect">
+                                  <p:stCondLst>
+                                    <p:cond delay="0"/>
+                                  </p:stCondLst>
+                                  <p:childTnLst>
+                                    <p:set>
+                                      <p:cBhvr>
+                                        <p:cTn id="6" dur="1" fill="hold">
+                                          <p:stCondLst>
+                                            <p:cond delay="0"/>
+                                          </p:stCondLst>
+                                        </p:cTn>
+                                        <p:tgtEl>
+                                          <p:spTgt spid="31"/>
+                                        </p:tgtEl>
+                                        <p:attrNameLst>
+                                          <p:attrName>style.visibility</p:attrName>
+                                        </p:attrNameLst>
+                                      </p:cBhvr>
+                                      <p:to>
+                                        <p:strVal val="visible"/>
+                                      </p:to>
+                                    </p:set>
+                                  </p:childTnLst>
+                                </p:cTn>
+                              </p:par>
+                            </p:childTnLst>
+                          </p:cTn>
+                        </p:par>
+                      </p:childTnLst>
+                    </p:cTn>
+                  </p:par>
+                  <p:par>
+                    <p:cTn id="7" fill="hold">
+                      <p:stCondLst>
+                        <p:cond delay="indefinite"/>
+                      </p:stCondLst>
+                      <p:childTnLst>
+                        <p:par>
+                          <p:cTn id="8" fill="hold">
+                            <p:stCondLst>
+                              <p:cond delay="0"/>
+                            </p:stCondLst>
+                            <p:childTnLst>
+                              <p:par>
+                                <p:cTn id="9" presetID="1" presetClass="entr" presetSubtype="0" fill="hold" nodeType="clickEffect">
+                                  <p:stCondLst>
+                                    <p:cond delay="0"/>
+                                  </p:stCondLst>
+                                  <p:childTnLst>
+                                    <p:set>
+                                      <p:cBhvr>
+                                        <p:cTn id="10" dur="1" fill="hold">
+                                          <p:stCondLst>
+                                            <p:cond delay="0"/>
+                                          </p:stCondLst>
+                                        </p:cTn>
+                                        <p:tgtEl>
+                                          <p:spTgt spid="27"/>
+                                        </p:tgtEl>
+                                        <p:attrNameLst>
+                                          <p:attrName>style.visibility</p:attrName>
+                                        </p:attrNameLst>
+                                      </p:cBhvr>
+                                      <p:to>
+                                        <p:strVal val="visible"/>
+                                      </p:to>
+                                    </p:set>
+                                  </p:childTnLst>
+                                </p:cTn>
+                              </p:par>
+                            </p:childTnLst>
+                          </p:cTn>
+                        </p:par>
+                      </p:childTnLst>
+                    </p:cTn>
+                  </p:par>
+                  <p:par>
+                    <p:cTn id="11" fill="hold">
+                      <p:stCondLst>
+                        <p:cond delay="indefinite"/>
+                      </p:stCondLst>
+                      <p:childTnLst>
+                        <p:par>
+                          <p:cTn id="12" fill="hold">
+                            <p:stCondLst>
+                              <p:cond delay="0"/>
+                            </p:stCondLst>
+                            <p:childTnLst>
+                              <p:par>
+                                <p:cTn id="13" presetID="1" presetClass="entr" presetSubtype="0" fill="hold" nodeType="clickEffect">
+                                  <p:stCondLst>
+                                    <p:cond delay="0"/>
+                                  </p:stCondLst>
+                                  <p:childTnLst>
+                                    <p:set>
+                                      <p:cBhvr>
+                                        <p:cTn id="14" dur="1" fill="hold">
+                                          <p:stCondLst>
+                                            <p:cond delay="0"/>
+                                          </p:stCondLst>
+                                        </p:cTn>
+                                        <p:tgtEl>
+                                          <p:spTgt spid="30"/>
+                                        </p:tgtEl>
+                                        <p:attrNameLst>
+                                          <p:attrName>style.visibility</p:attrName>
+                                        </p:attrNameLst>
+                                      </p:cBhvr>
+                                      <p:to>
+                                        <p:strVal val="visible"/>
+                                      </p:to>
+                                    </p:set>
+                                  </p:childTnLst>
+                                </p:cTn>
+                              </p:par>
+                            </p:childTnLst>
+                          </p:cTn>
+                        </p:par>
+                      </p:childTnLst>
+                    </p:cTn>
+                  </p:par>
+                  <p:par>
+                    <p:cTn id="15" fill="hold">
+                      <p:stCondLst>
+                        <p:cond delay="indefinite"/>
+                      </p:stCondLst>
+                      <p:childTnLst>
+                        <p:par>
+                          <p:cTn id="16" fill="hold">
+                            <p:stCondLst>
+                              <p:cond delay="0"/>
+                            </p:stCondLst>
+                            <p:childTnLst>
+                              <p:par>
+                                <p:cTn id="17" presetID="1" presetClass="entr" presetSubtype="0" fill="hold" nodeType="clickEffect">
+                                  <p:stCondLst>
+                                    <p:cond delay="0"/>
+                                  </p:stCondLst>
+                                  <p:childTnLst>
+                                    <p:set>
+                                      <p:cBhvr>
+                                        <p:cTn id="18" dur="1" fill="hold">
+                                          <p:stCondLst>
+                                            <p:cond delay="0"/>
+                                          </p:stCondLst>
+                                        </p:cTn>
+                                        <p:tgtEl>
+                                          <p:spTgt spid="26"/>
+                                        </p:tgtEl>
+                                        <p:attrNameLst>
+                                          <p:attrName>style.visibility</p:attrName>
+                                        </p:attrNameLst>
+                                      </p:cBhvr>
+                                      <p:to>
+                                        <p:strVal val="visible"/>
+                                      </p:to>
+                                    </p:set>
+                                  </p:childTnLst>
+                                </p:cTn>
+                              </p:par>
+                            </p:childTnLst>
+                          </p:cTn>
+                        </p:par>
+                      </p:childTnLst>
+                    </p:cTn>
+                  </p:par>
+                  <p:par>
+                    <p:cTn id="19" fill="hold">
+                      <p:stCondLst>
+                        <p:cond delay="indefinite"/>
+                      </p:stCondLst>
+                      <p:childTnLst>
+                        <p:par>
+                          <p:cTn id="20" fill="hold">
+                            <p:stCondLst>
+                              <p:cond delay="0"/>
+                            </p:stCondLst>
+                            <p:childTnLst>
+                              <p:par>
+                                <p:cTn id="21" presetID="1" presetClass="entr" presetSubtype="0" fill="hold" nodeType="clickEffect">
+                                  <p:stCondLst>
+                                    <p:cond delay="0"/>
+                                  </p:stCondLst>
+                                  <p:childTnLst>
+                                    <p:set>
+                                      <p:cBhvr>
+                                        <p:cTn id="22" dur="1" fill="hold">
+                                          <p:stCondLst>
+                                            <p:cond delay="0"/>
+                                          </p:stCondLst>
+                                        </p:cTn>
+                                        <p:tgtEl>
+                                          <p:spTgt spid="29"/>
+                                        </p:tgtEl>
+                                        <p:attrNameLst>
+                                          <p:attrName>style.visibility</p:attrName>
+                                        </p:attrNameLst>
+                                      </p:cBhvr>
+                                      <p:to>
+                                        <p:strVal val="visible"/>
+                                      </p:to>
+                                    </p:set>
+                                  </p:childTnLst>
+                                </p:cTn>
+                              </p:par>
+                            </p:childTnLst>
+                          </p:cTn>
+                        </p:par>
+                      </p:childTnLst>
+                    </p:cTn>
+                  </p:par>
+                </p:childTnLst>
+              </p:cTn>
+              <p:prevCondLst>
+                <p:cond evt="onPrev" delay="0">
+                  <p:tgtEl>
+                    <p:sldTgt/>
+                  </p:tgtEl>
+                </p:cond>
+              </p:prevCondLst>
+              <p:nextCondLst>
+                <p:cond evt="onNext" delay="0">
+                  <p:tgtEl>
+                    <p:sldTgt/>
+                  </p:tgtEl>
+                </p:cond>
+              </p:nextCondLst>
+            </p:seq>
+          </p:childTnLst>
+        </p:cTn>
+      </p:par>
+    </p:tnLst>
+  </p:timing>
 </p:sld>
 </file>
 
@@ -3498,7 +3930,27 @@
                   <a:latin typeface="Calibri" pitchFamily="34" charset="0"/>
                   <a:cs typeface="Calibri" pitchFamily="34" charset="-120"/>
                 </a:rPr>
-                <a:t>IMPORTANT: Dataset is outdated. Need more recent data to find stronger signals.</a:t>
+                <a:t>IMPORTANT</a:t>
+              </a:r>
+              <a:r>
+                <a:rPr lang="en-US" sz="1100" b="1">
+                  <a:solidFill>
+                    <a:srgbClr val="FFFFFF"/>
+                  </a:solidFill>
+                  <a:latin typeface="Calibri" pitchFamily="34" charset="0"/>
+                  <a:cs typeface="Calibri" pitchFamily="34" charset="-120"/>
+                </a:rPr>
+                <a:t>: Need </a:t>
+              </a:r>
+              <a:r>
+                <a:rPr lang="en-US" sz="1100" b="1" dirty="0">
+                  <a:solidFill>
+                    <a:srgbClr val="FFFFFF"/>
+                  </a:solidFill>
+                  <a:latin typeface="Calibri" pitchFamily="34" charset="0"/>
+                  <a:cs typeface="Calibri" pitchFamily="34" charset="-120"/>
+                </a:rPr>
+                <a:t>more recent data to find stronger signals.</a:t>
               </a:r>
               <a:endParaRPr lang="en-US" sz="1100" dirty="0"/>
             </a:p>
@@ -3759,7 +4211,7 @@
                 <a:ea typeface="Calibri" pitchFamily="34" charset="-122"/>
                 <a:cs typeface="Calibri" pitchFamily="34" charset="-120"/>
               </a:rPr>
-              <a:t>4-6 weeks</a:t>
+              <a:t>2 weeks</a:t>
             </a:r>
             <a:endParaRPr lang="en-US" sz="900" dirty="0"/>
           </a:p>
@@ -4190,7 +4642,7 @@
                 <a:ea typeface="Calibri" pitchFamily="34" charset="-122"/>
                 <a:cs typeface="Calibri" pitchFamily="34" charset="-120"/>
               </a:rPr>
-              <a:t>8-12 weeks</a:t>
+              <a:t>4 weeks</a:t>
             </a:r>
             <a:endParaRPr lang="en-US" sz="900" dirty="0"/>
           </a:p>
@@ -4621,7 +5073,7 @@
                 <a:ea typeface="Calibri" pitchFamily="34" charset="-122"/>
                 <a:cs typeface="Calibri" pitchFamily="34" charset="-120"/>
               </a:rPr>
-              <a:t>8-12 weeks</a:t>
+              <a:t>4 weeks</a:t>
             </a:r>
             <a:endParaRPr lang="en-US" sz="900" dirty="0"/>
           </a:p>
@@ -5568,678 +6020,976 @@
           </a:p>
         </p:txBody>
       </p:sp>
-      <p:sp>
-        <p:nvSpPr>
-          <p:cNvPr id="4" name="Shape 2"/>
-          <p:cNvSpPr/>
-          <p:nvPr/>
-        </p:nvSpPr>
-        <p:spPr>
+      <p:grpSp>
+        <p:nvGrpSpPr>
+          <p:cNvPr id="20" name="Group 19">
+            <a:extLst>
+              <a:ext uri="{FF2B5EF4-FFF2-40B4-BE49-F238E27FC236}">
+                <a16:creationId xmlns:a16="http://schemas.microsoft.com/office/drawing/2014/main" id="{D3A2DDFE-28BE-5294-D1B4-64EA4B9A15A2}"/>
+              </a:ext>
+            </a:extLst>
+          </p:cNvPr>
+          <p:cNvGrpSpPr/>
+          <p:nvPr/>
+        </p:nvGrpSpPr>
+        <p:grpSpPr>
           <a:xfrm>
             <a:off x="475488" y="1325880"/>
             <a:ext cx="2651760" cy="2377440"/>
-          </a:xfrm>
-          <a:prstGeom prst="rect">
-            <a:avLst/>
-          </a:prstGeom>
-          <a:solidFill>
-            <a:srgbClr val="163A5A"/>
-          </a:solidFill>
-          <a:ln w="12700">
+            <a:chOff x="475488" y="1325880"/>
+            <a:chExt cx="2651760" cy="2377440"/>
+          </a:xfrm>
+        </p:grpSpPr>
+        <p:sp>
+          <p:nvSpPr>
+            <p:cNvPr id="4" name="Shape 2"/>
+            <p:cNvSpPr/>
+            <p:nvPr/>
+          </p:nvSpPr>
+          <p:spPr>
+            <a:xfrm>
+              <a:off x="475488" y="1325880"/>
+              <a:ext cx="2651760" cy="2377440"/>
+            </a:xfrm>
+            <a:prstGeom prst="rect">
+              <a:avLst/>
+            </a:prstGeom>
             <a:solidFill>
-              <a:srgbClr val="2E74B5"/>
+              <a:srgbClr val="163A5A"/>
             </a:solidFill>
-            <a:prstDash val="solid"/>
-          </a:ln>
-          <a:effectLst>
-            <a:outerShdw blurRad="101600" dist="38100" dir="8100000" algn="bl" rotWithShape="0">
-              <a:srgbClr val="000000">
-                <a:alpha val="10000"/>
-              </a:srgbClr>
-            </a:outerShdw>
-          </a:effectLst>
-        </p:spPr>
-        <p:txBody>
-          <a:bodyPr/>
-          <a:lstStyle/>
-          <a:p>
-            <a:endParaRPr lang="en-DE"/>
-          </a:p>
-        </p:txBody>
-      </p:sp>
-      <p:sp>
-        <p:nvSpPr>
-          <p:cNvPr id="5" name="Text 3"/>
-          <p:cNvSpPr/>
-          <p:nvPr/>
-        </p:nvSpPr>
-        <p:spPr>
-          <a:xfrm>
-            <a:off x="640080" y="1444752"/>
-            <a:ext cx="594360" cy="457200"/>
-          </a:xfrm>
-          <a:prstGeom prst="rect">
-            <a:avLst/>
-          </a:prstGeom>
-          <a:noFill/>
-          <a:ln/>
-        </p:spPr>
-        <p:txBody>
-          <a:bodyPr wrap="square" lIns="0" tIns="0" rIns="0" bIns="0" rtlCol="0" anchor="ctr"/>
-          <a:lstStyle/>
-          <a:p>
-            <a:pPr marL="0" indent="0" algn="l">
-              <a:buNone/>
-            </a:pPr>
-            <a:r>
-              <a:rPr lang="en-US" sz="2600" b="1" dirty="0">
-                <a:solidFill>
-                  <a:srgbClr val="2E74B5"/>
-                </a:solidFill>
-                <a:latin typeface="Cambria" pitchFamily="34" charset="0"/>
-                <a:ea typeface="Cambria" pitchFamily="34" charset="-122"/>
-                <a:cs typeface="Cambria" pitchFamily="34" charset="-120"/>
-              </a:rPr>
-              <a:t>01</a:t>
-            </a:r>
-            <a:endParaRPr lang="en-US" sz="2600" dirty="0"/>
-          </a:p>
-        </p:txBody>
-      </p:sp>
-      <p:sp>
-        <p:nvSpPr>
-          <p:cNvPr id="6" name="Text 4"/>
-          <p:cNvSpPr/>
-          <p:nvPr/>
-        </p:nvSpPr>
-        <p:spPr>
-          <a:xfrm>
-            <a:off x="640080" y="1938528"/>
-            <a:ext cx="2331720" cy="320040"/>
-          </a:xfrm>
-          <a:prstGeom prst="rect">
-            <a:avLst/>
-          </a:prstGeom>
-          <a:noFill/>
-          <a:ln/>
-        </p:spPr>
-        <p:txBody>
-          <a:bodyPr wrap="square" lIns="0" tIns="0" rIns="0" bIns="0" rtlCol="0" anchor="ctr"/>
-          <a:lstStyle/>
-          <a:p>
-            <a:pPr marL="0" indent="0" algn="l">
-              <a:buNone/>
-            </a:pPr>
-            <a:r>
-              <a:rPr lang="en-US" sz="1400" b="1" dirty="0">
-                <a:solidFill>
-                  <a:srgbClr val="FFFFFF"/>
-                </a:solidFill>
-                <a:latin typeface="Cambria" pitchFamily="34" charset="0"/>
-                <a:ea typeface="Cambria" pitchFamily="34" charset="-122"/>
-                <a:cs typeface="Cambria" pitchFamily="34" charset="-120"/>
-              </a:rPr>
-              <a:t>AI is great. </a:t>
-            </a:r>
-            <a:br>
-              <a:rPr lang="en-US" sz="1400" b="1" dirty="0">
-                <a:solidFill>
-                  <a:srgbClr val="FFFFFF"/>
-                </a:solidFill>
-                <a:latin typeface="Cambria" pitchFamily="34" charset="0"/>
-                <a:ea typeface="Cambria" pitchFamily="34" charset="-122"/>
-                <a:cs typeface="Cambria" pitchFamily="34" charset="-120"/>
-              </a:rPr>
-            </a:br>
-            <a:r>
-              <a:rPr lang="en-US" sz="1400" b="1" dirty="0">
-                <a:solidFill>
-                  <a:srgbClr val="FFFFFF"/>
-                </a:solidFill>
-                <a:latin typeface="Cambria" pitchFamily="34" charset="0"/>
-                <a:ea typeface="Cambria" pitchFamily="34" charset="-122"/>
-                <a:cs typeface="Cambria" pitchFamily="34" charset="-120"/>
-              </a:rPr>
-              <a:t>Real Data is better.</a:t>
-            </a:r>
-            <a:endParaRPr lang="en-US" sz="1400" dirty="0"/>
-          </a:p>
-        </p:txBody>
-      </p:sp>
-      <p:sp>
-        <p:nvSpPr>
-          <p:cNvPr id="7" name="Text 5"/>
-          <p:cNvSpPr/>
-          <p:nvPr/>
-        </p:nvSpPr>
-        <p:spPr>
-          <a:xfrm>
-            <a:off x="640080" y="2286000"/>
-            <a:ext cx="2331720" cy="1234440"/>
-          </a:xfrm>
-          <a:prstGeom prst="rect">
-            <a:avLst/>
-          </a:prstGeom>
-          <a:noFill/>
-          <a:ln/>
-        </p:spPr>
-        <p:txBody>
-          <a:bodyPr wrap="square" lIns="0" tIns="0" rIns="0" bIns="0" rtlCol="0" anchor="ctr"/>
-          <a:lstStyle/>
-          <a:p>
-            <a:r>
-              <a:rPr lang="en-US" sz="1100" dirty="0">
-                <a:solidFill>
-                  <a:srgbClr val="B0BEC5"/>
-                </a:solidFill>
-                <a:latin typeface="Calibri" pitchFamily="34" charset="0"/>
-                <a:ea typeface="Calibri" pitchFamily="34" charset="-122"/>
-                <a:cs typeface="Calibri" pitchFamily="34" charset="-120"/>
-              </a:rPr>
-              <a:t>AI to cut churn by 30% sounds great but does not work according to the data. That led to focus even more on signaling and CS prepping.</a:t>
-            </a:r>
-            <a:endParaRPr lang="en-US" sz="1100" dirty="0"/>
-          </a:p>
-        </p:txBody>
-      </p:sp>
-      <p:sp>
-        <p:nvSpPr>
-          <p:cNvPr id="8" name="Shape 6"/>
-          <p:cNvSpPr/>
-          <p:nvPr/>
-        </p:nvSpPr>
-        <p:spPr>
+            <a:ln w="12700">
+              <a:solidFill>
+                <a:srgbClr val="2E74B5"/>
+              </a:solidFill>
+              <a:prstDash val="solid"/>
+            </a:ln>
+            <a:effectLst>
+              <a:outerShdw blurRad="101600" dist="38100" dir="8100000" algn="bl" rotWithShape="0">
+                <a:srgbClr val="000000">
+                  <a:alpha val="10000"/>
+                </a:srgbClr>
+              </a:outerShdw>
+            </a:effectLst>
+          </p:spPr>
+          <p:txBody>
+            <a:bodyPr/>
+            <a:lstStyle/>
+            <a:p>
+              <a:endParaRPr lang="en-DE"/>
+            </a:p>
+          </p:txBody>
+        </p:sp>
+        <p:sp>
+          <p:nvSpPr>
+            <p:cNvPr id="5" name="Text 3"/>
+            <p:cNvSpPr/>
+            <p:nvPr/>
+          </p:nvSpPr>
+          <p:spPr>
+            <a:xfrm>
+              <a:off x="640080" y="1444752"/>
+              <a:ext cx="594360" cy="457200"/>
+            </a:xfrm>
+            <a:prstGeom prst="rect">
+              <a:avLst/>
+            </a:prstGeom>
+            <a:noFill/>
+            <a:ln/>
+          </p:spPr>
+          <p:txBody>
+            <a:bodyPr wrap="square" lIns="0" tIns="0" rIns="0" bIns="0" rtlCol="0" anchor="ctr"/>
+            <a:lstStyle/>
+            <a:p>
+              <a:pPr marL="0" indent="0" algn="l">
+                <a:buNone/>
+              </a:pPr>
+              <a:r>
+                <a:rPr lang="en-US" sz="2600" b="1" dirty="0">
+                  <a:solidFill>
+                    <a:srgbClr val="2E74B5"/>
+                  </a:solidFill>
+                  <a:latin typeface="Cambria" pitchFamily="34" charset="0"/>
+                  <a:ea typeface="Cambria" pitchFamily="34" charset="-122"/>
+                  <a:cs typeface="Cambria" pitchFamily="34" charset="-120"/>
+                </a:rPr>
+                <a:t>01</a:t>
+              </a:r>
+              <a:endParaRPr lang="en-US" sz="2600" dirty="0"/>
+            </a:p>
+          </p:txBody>
+        </p:sp>
+        <p:sp>
+          <p:nvSpPr>
+            <p:cNvPr id="6" name="Text 4"/>
+            <p:cNvSpPr/>
+            <p:nvPr/>
+          </p:nvSpPr>
+          <p:spPr>
+            <a:xfrm>
+              <a:off x="640080" y="1938528"/>
+              <a:ext cx="2331720" cy="320040"/>
+            </a:xfrm>
+            <a:prstGeom prst="rect">
+              <a:avLst/>
+            </a:prstGeom>
+            <a:noFill/>
+            <a:ln/>
+          </p:spPr>
+          <p:txBody>
+            <a:bodyPr wrap="square" lIns="0" tIns="0" rIns="0" bIns="0" rtlCol="0" anchor="ctr"/>
+            <a:lstStyle/>
+            <a:p>
+              <a:pPr marL="0" indent="0" algn="l">
+                <a:buNone/>
+              </a:pPr>
+              <a:r>
+                <a:rPr lang="en-US" sz="1400" b="1" dirty="0">
+                  <a:solidFill>
+                    <a:srgbClr val="FFFFFF"/>
+                  </a:solidFill>
+                  <a:latin typeface="Cambria" pitchFamily="34" charset="0"/>
+                  <a:ea typeface="Cambria" pitchFamily="34" charset="-122"/>
+                  <a:cs typeface="Cambria" pitchFamily="34" charset="-120"/>
+                </a:rPr>
+                <a:t>AI is great. </a:t>
+              </a:r>
+              <a:br>
+                <a:rPr lang="en-US" sz="1400" b="1" dirty="0">
+                  <a:solidFill>
+                    <a:srgbClr val="FFFFFF"/>
+                  </a:solidFill>
+                  <a:latin typeface="Cambria" pitchFamily="34" charset="0"/>
+                  <a:ea typeface="Cambria" pitchFamily="34" charset="-122"/>
+                  <a:cs typeface="Cambria" pitchFamily="34" charset="-120"/>
+                </a:rPr>
+              </a:br>
+              <a:r>
+                <a:rPr lang="en-US" sz="1400" b="1" dirty="0">
+                  <a:solidFill>
+                    <a:srgbClr val="FFFFFF"/>
+                  </a:solidFill>
+                  <a:latin typeface="Cambria" pitchFamily="34" charset="0"/>
+                  <a:ea typeface="Cambria" pitchFamily="34" charset="-122"/>
+                  <a:cs typeface="Cambria" pitchFamily="34" charset="-120"/>
+                </a:rPr>
+                <a:t>Real Data is better.</a:t>
+              </a:r>
+              <a:endParaRPr lang="en-US" sz="1400" dirty="0"/>
+            </a:p>
+          </p:txBody>
+        </p:sp>
+        <p:sp>
+          <p:nvSpPr>
+            <p:cNvPr id="7" name="Text 5"/>
+            <p:cNvSpPr/>
+            <p:nvPr/>
+          </p:nvSpPr>
+          <p:spPr>
+            <a:xfrm>
+              <a:off x="640080" y="2286000"/>
+              <a:ext cx="2331720" cy="1234440"/>
+            </a:xfrm>
+            <a:prstGeom prst="rect">
+              <a:avLst/>
+            </a:prstGeom>
+            <a:noFill/>
+            <a:ln/>
+          </p:spPr>
+          <p:txBody>
+            <a:bodyPr wrap="square" lIns="0" tIns="0" rIns="0" bIns="0" rtlCol="0" anchor="ctr"/>
+            <a:lstStyle/>
+            <a:p>
+              <a:r>
+                <a:rPr lang="en-US" sz="1100" dirty="0">
+                  <a:solidFill>
+                    <a:srgbClr val="B0BEC5"/>
+                  </a:solidFill>
+                  <a:latin typeface="Calibri"/>
+                  <a:ea typeface="Calibri"/>
+                  <a:cs typeface="Calibri"/>
+                </a:rPr>
+                <a:t>AI to cut churn by 30% sounds great but does not work according to the data. </a:t>
+              </a:r>
+              <a:r>
+                <a:rPr lang="en-US" sz="1100">
+                  <a:solidFill>
+                    <a:srgbClr val="B0BEC5"/>
+                  </a:solidFill>
+                  <a:latin typeface="Calibri"/>
+                  <a:ea typeface="Calibri"/>
+                  <a:cs typeface="Calibri"/>
+                </a:rPr>
+                <a:t>The approach needs to focus</a:t>
+              </a:r>
+              <a:r>
+                <a:rPr lang="en-US" sz="1100" dirty="0">
+                  <a:solidFill>
+                    <a:srgbClr val="B0BEC5"/>
+                  </a:solidFill>
+                  <a:latin typeface="Calibri"/>
+                  <a:ea typeface="Calibri"/>
+                  <a:cs typeface="Calibri"/>
+                </a:rPr>
+                <a:t> even more on signaling and CS prepping.</a:t>
+              </a:r>
+              <a:endParaRPr lang="en-US" sz="1100" dirty="0">
+                <a:latin typeface="Calibri"/>
+                <a:ea typeface="Calibri"/>
+                <a:cs typeface="Calibri"/>
+              </a:endParaRPr>
+            </a:p>
+          </p:txBody>
+        </p:sp>
+      </p:grpSp>
+      <p:grpSp>
+        <p:nvGrpSpPr>
+          <p:cNvPr id="21" name="Group 20">
+            <a:extLst>
+              <a:ext uri="{FF2B5EF4-FFF2-40B4-BE49-F238E27FC236}">
+                <a16:creationId xmlns:a16="http://schemas.microsoft.com/office/drawing/2014/main" id="{BF8D96F5-4306-B40B-B99A-EC09BAC59432}"/>
+              </a:ext>
+            </a:extLst>
+          </p:cNvPr>
+          <p:cNvGrpSpPr/>
+          <p:nvPr/>
+        </p:nvGrpSpPr>
+        <p:grpSpPr>
           <a:xfrm>
             <a:off x="3310128" y="1325880"/>
             <a:ext cx="2651760" cy="2377440"/>
-          </a:xfrm>
-          <a:prstGeom prst="rect">
-            <a:avLst/>
-          </a:prstGeom>
-          <a:solidFill>
-            <a:srgbClr val="163A5A"/>
-          </a:solidFill>
-          <a:ln w="12700">
+            <a:chOff x="3310128" y="1325880"/>
+            <a:chExt cx="2651760" cy="2377440"/>
+          </a:xfrm>
+        </p:grpSpPr>
+        <p:sp>
+          <p:nvSpPr>
+            <p:cNvPr id="8" name="Shape 6"/>
+            <p:cNvSpPr/>
+            <p:nvPr/>
+          </p:nvSpPr>
+          <p:spPr>
+            <a:xfrm>
+              <a:off x="3310128" y="1325880"/>
+              <a:ext cx="2651760" cy="2377440"/>
+            </a:xfrm>
+            <a:prstGeom prst="rect">
+              <a:avLst/>
+            </a:prstGeom>
             <a:solidFill>
-              <a:srgbClr val="2E74B5"/>
+              <a:srgbClr val="163A5A"/>
             </a:solidFill>
-            <a:prstDash val="solid"/>
-          </a:ln>
-          <a:effectLst>
-            <a:outerShdw blurRad="101600" dist="38100" dir="8100000" algn="bl" rotWithShape="0">
-              <a:srgbClr val="000000">
-                <a:alpha val="10000"/>
-              </a:srgbClr>
-            </a:outerShdw>
-          </a:effectLst>
-        </p:spPr>
-        <p:txBody>
-          <a:bodyPr/>
-          <a:lstStyle/>
-          <a:p>
-            <a:endParaRPr lang="en-DE"/>
-          </a:p>
-        </p:txBody>
-      </p:sp>
-      <p:sp>
-        <p:nvSpPr>
-          <p:cNvPr id="9" name="Text 7"/>
-          <p:cNvSpPr/>
-          <p:nvPr/>
-        </p:nvSpPr>
-        <p:spPr>
-          <a:xfrm>
-            <a:off x="3474720" y="1444752"/>
-            <a:ext cx="594360" cy="457200"/>
-          </a:xfrm>
-          <a:prstGeom prst="rect">
-            <a:avLst/>
-          </a:prstGeom>
-          <a:noFill/>
-          <a:ln/>
-        </p:spPr>
-        <p:txBody>
-          <a:bodyPr wrap="square" lIns="0" tIns="0" rIns="0" bIns="0" rtlCol="0" anchor="ctr"/>
-          <a:lstStyle/>
-          <a:p>
-            <a:pPr marL="0" indent="0" algn="l">
-              <a:buNone/>
-            </a:pPr>
-            <a:r>
-              <a:rPr lang="en-US" sz="2600" b="1" dirty="0">
-                <a:solidFill>
-                  <a:srgbClr val="2E74B5"/>
-                </a:solidFill>
-                <a:latin typeface="Cambria" pitchFamily="34" charset="0"/>
-                <a:ea typeface="Cambria" pitchFamily="34" charset="-122"/>
-                <a:cs typeface="Cambria" pitchFamily="34" charset="-120"/>
-              </a:rPr>
-              <a:t>02</a:t>
-            </a:r>
-            <a:endParaRPr lang="en-US" sz="2600" dirty="0"/>
-          </a:p>
-        </p:txBody>
-      </p:sp>
-      <p:sp>
-        <p:nvSpPr>
-          <p:cNvPr id="10" name="Text 8"/>
-          <p:cNvSpPr/>
-          <p:nvPr/>
-        </p:nvSpPr>
-        <p:spPr>
-          <a:xfrm>
-            <a:off x="3474720" y="1938528"/>
-            <a:ext cx="2331720" cy="320040"/>
-          </a:xfrm>
-          <a:prstGeom prst="rect">
-            <a:avLst/>
-          </a:prstGeom>
-          <a:noFill/>
-          <a:ln/>
-        </p:spPr>
-        <p:txBody>
-          <a:bodyPr wrap="square" lIns="0" tIns="0" rIns="0" bIns="0" rtlCol="0" anchor="ctr"/>
-          <a:lstStyle/>
-          <a:p>
-            <a:pPr marL="0" indent="0" algn="l">
-              <a:buNone/>
-            </a:pPr>
-            <a:r>
-              <a:rPr lang="en-US" sz="1400" b="1" dirty="0">
-                <a:solidFill>
-                  <a:srgbClr val="FFFFFF"/>
-                </a:solidFill>
-                <a:latin typeface="Cambria" pitchFamily="34" charset="0"/>
-                <a:ea typeface="Cambria" pitchFamily="34" charset="-122"/>
-                <a:cs typeface="Cambria" pitchFamily="34" charset="-120"/>
-              </a:rPr>
-              <a:t>Focus, Focus, Focus.</a:t>
-            </a:r>
-            <a:endParaRPr lang="en-US" sz="1400" dirty="0"/>
-          </a:p>
-        </p:txBody>
-      </p:sp>
-      <p:sp>
-        <p:nvSpPr>
-          <p:cNvPr id="11" name="Text 9"/>
-          <p:cNvSpPr/>
-          <p:nvPr/>
-        </p:nvSpPr>
-        <p:spPr>
-          <a:xfrm>
-            <a:off x="3474720" y="2286000"/>
-            <a:ext cx="2331720" cy="1234440"/>
-          </a:xfrm>
-          <a:prstGeom prst="rect">
-            <a:avLst/>
-          </a:prstGeom>
-          <a:noFill/>
-          <a:ln/>
-        </p:spPr>
-        <p:txBody>
-          <a:bodyPr wrap="square" lIns="0" tIns="0" rIns="0" bIns="0" rtlCol="0" anchor="ctr"/>
-          <a:lstStyle/>
-          <a:p>
-            <a:pPr marL="0" indent="0" algn="l">
-              <a:buNone/>
-            </a:pPr>
-            <a:r>
-              <a:rPr lang="en-US" sz="1100" dirty="0">
-                <a:solidFill>
-                  <a:srgbClr val="B0BEC5"/>
-                </a:solidFill>
-                <a:latin typeface="Calibri" pitchFamily="34" charset="0"/>
-                <a:ea typeface="Calibri" pitchFamily="34" charset="-122"/>
-                <a:cs typeface="Calibri" pitchFamily="34" charset="-120"/>
-              </a:rPr>
-              <a:t>The data tells a clear story. Customer Success needs clear signals to help with root cause analysis, budget justification and support escalations.</a:t>
-            </a:r>
-          </a:p>
-        </p:txBody>
-      </p:sp>
-      <p:sp>
-        <p:nvSpPr>
-          <p:cNvPr id="12" name="Shape 10"/>
-          <p:cNvSpPr/>
-          <p:nvPr/>
-        </p:nvSpPr>
-        <p:spPr>
-          <a:xfrm>
-            <a:off x="6144768" y="1325880"/>
-            <a:ext cx="2651760" cy="2377440"/>
-          </a:xfrm>
-          <a:prstGeom prst="rect">
-            <a:avLst/>
-          </a:prstGeom>
-          <a:solidFill>
-            <a:srgbClr val="163A5A"/>
-          </a:solidFill>
-          <a:ln w="12700">
-            <a:solidFill>
-              <a:srgbClr val="2E74B5"/>
-            </a:solidFill>
-            <a:prstDash val="solid"/>
-          </a:ln>
-          <a:effectLst>
-            <a:outerShdw blurRad="101600" dist="38100" dir="8100000" algn="bl" rotWithShape="0">
-              <a:srgbClr val="000000">
-                <a:alpha val="10000"/>
-              </a:srgbClr>
-            </a:outerShdw>
-          </a:effectLst>
-        </p:spPr>
-        <p:txBody>
-          <a:bodyPr/>
-          <a:lstStyle/>
-          <a:p>
-            <a:endParaRPr lang="en-DE"/>
-          </a:p>
-        </p:txBody>
-      </p:sp>
-      <p:sp>
-        <p:nvSpPr>
-          <p:cNvPr id="13" name="Text 11"/>
-          <p:cNvSpPr/>
-          <p:nvPr/>
-        </p:nvSpPr>
-        <p:spPr>
-          <a:xfrm>
-            <a:off x="6309360" y="1444752"/>
-            <a:ext cx="594360" cy="457200"/>
-          </a:xfrm>
-          <a:prstGeom prst="rect">
-            <a:avLst/>
-          </a:prstGeom>
-          <a:noFill/>
-          <a:ln/>
-        </p:spPr>
-        <p:txBody>
-          <a:bodyPr wrap="square" lIns="0" tIns="0" rIns="0" bIns="0" rtlCol="0" anchor="ctr"/>
-          <a:lstStyle/>
-          <a:p>
-            <a:pPr marL="0" indent="0" algn="l">
-              <a:buNone/>
-            </a:pPr>
-            <a:r>
-              <a:rPr lang="en-US" sz="2600" b="1" dirty="0">
-                <a:solidFill>
-                  <a:srgbClr val="2E74B5"/>
-                </a:solidFill>
-                <a:latin typeface="Cambria" pitchFamily="34" charset="0"/>
-                <a:ea typeface="Cambria" pitchFamily="34" charset="-122"/>
-                <a:cs typeface="Cambria" pitchFamily="34" charset="-120"/>
-              </a:rPr>
-              <a:t>03</a:t>
-            </a:r>
-            <a:endParaRPr lang="en-US" sz="2600" dirty="0"/>
-          </a:p>
-        </p:txBody>
-      </p:sp>
-      <p:sp>
-        <p:nvSpPr>
-          <p:cNvPr id="14" name="Text 12"/>
-          <p:cNvSpPr/>
-          <p:nvPr/>
-        </p:nvSpPr>
-        <p:spPr>
-          <a:xfrm>
-            <a:off x="6309360" y="1938528"/>
-            <a:ext cx="2331720" cy="320040"/>
-          </a:xfrm>
-          <a:prstGeom prst="rect">
-            <a:avLst/>
-          </a:prstGeom>
-          <a:noFill/>
-          <a:ln/>
-        </p:spPr>
-        <p:txBody>
-          <a:bodyPr wrap="square" lIns="0" tIns="0" rIns="0" bIns="0" rtlCol="0" anchor="ctr"/>
-          <a:lstStyle/>
-          <a:p>
-            <a:pPr marL="0" indent="0" algn="l">
-              <a:buNone/>
-            </a:pPr>
-            <a:r>
-              <a:rPr lang="en-US" sz="1400" b="1" dirty="0">
-                <a:solidFill>
-                  <a:srgbClr val="FFFFFF"/>
-                </a:solidFill>
-                <a:latin typeface="Cambria" pitchFamily="34" charset="0"/>
-                <a:ea typeface="Cambria" pitchFamily="34" charset="-122"/>
-                <a:cs typeface="Cambria" pitchFamily="34" charset="-120"/>
-              </a:rPr>
-              <a:t>Iteration is key to success.</a:t>
-            </a:r>
-            <a:endParaRPr lang="en-US" sz="1400" dirty="0"/>
-          </a:p>
-        </p:txBody>
-      </p:sp>
-      <p:sp>
-        <p:nvSpPr>
-          <p:cNvPr id="15" name="Text 13"/>
-          <p:cNvSpPr/>
-          <p:nvPr/>
-        </p:nvSpPr>
-        <p:spPr>
-          <a:xfrm>
-            <a:off x="6309360" y="2286000"/>
-            <a:ext cx="2331720" cy="1234440"/>
-          </a:xfrm>
-          <a:prstGeom prst="rect">
-            <a:avLst/>
-          </a:prstGeom>
-          <a:noFill/>
-          <a:ln/>
-        </p:spPr>
-        <p:txBody>
-          <a:bodyPr wrap="square" lIns="0" tIns="0" rIns="0" bIns="0" rtlCol="0" anchor="ctr"/>
-          <a:lstStyle/>
-          <a:p>
-            <a:pPr marL="0" indent="0" algn="l">
-              <a:buNone/>
-            </a:pPr>
-            <a:r>
-              <a:rPr lang="en-US" sz="1100" dirty="0">
-                <a:solidFill>
-                  <a:srgbClr val="B0BEC5"/>
-                </a:solidFill>
-                <a:latin typeface="Calibri" pitchFamily="34" charset="0"/>
-                <a:ea typeface="Calibri" pitchFamily="34" charset="-122"/>
-                <a:cs typeface="Calibri" pitchFamily="34" charset="-120"/>
-              </a:rPr>
-              <a:t>$8–12K internal pilot with a go/no-go at Phase 1 protects you from an uninformed decision that locks you into $300k+ investment.</a:t>
-            </a:r>
-            <a:endParaRPr lang="en-US" sz="1100" dirty="0"/>
-          </a:p>
-        </p:txBody>
-      </p:sp>
-      <p:sp>
-        <p:nvSpPr>
-          <p:cNvPr id="16" name="Shape 14"/>
-          <p:cNvSpPr/>
-          <p:nvPr/>
-        </p:nvSpPr>
-        <p:spPr>
+            <a:ln w="12700">
+              <a:solidFill>
+                <a:srgbClr val="2E74B5"/>
+              </a:solidFill>
+              <a:prstDash val="solid"/>
+            </a:ln>
+            <a:effectLst>
+              <a:outerShdw blurRad="101600" dist="38100" dir="8100000" algn="bl" rotWithShape="0">
+                <a:srgbClr val="000000">
+                  <a:alpha val="10000"/>
+                </a:srgbClr>
+              </a:outerShdw>
+            </a:effectLst>
+          </p:spPr>
+          <p:txBody>
+            <a:bodyPr/>
+            <a:lstStyle/>
+            <a:p>
+              <a:endParaRPr lang="en-DE"/>
+            </a:p>
+          </p:txBody>
+        </p:sp>
+        <p:sp>
+          <p:nvSpPr>
+            <p:cNvPr id="9" name="Text 7"/>
+            <p:cNvSpPr/>
+            <p:nvPr/>
+          </p:nvSpPr>
+          <p:spPr>
+            <a:xfrm>
+              <a:off x="3474720" y="1444752"/>
+              <a:ext cx="594360" cy="457200"/>
+            </a:xfrm>
+            <a:prstGeom prst="rect">
+              <a:avLst/>
+            </a:prstGeom>
+            <a:noFill/>
+            <a:ln/>
+          </p:spPr>
+          <p:txBody>
+            <a:bodyPr wrap="square" lIns="0" tIns="0" rIns="0" bIns="0" rtlCol="0" anchor="ctr"/>
+            <a:lstStyle/>
+            <a:p>
+              <a:pPr marL="0" indent="0" algn="l">
+                <a:buNone/>
+              </a:pPr>
+              <a:r>
+                <a:rPr lang="en-US" sz="2600" b="1" dirty="0">
+                  <a:solidFill>
+                    <a:srgbClr val="2E74B5"/>
+                  </a:solidFill>
+                  <a:latin typeface="Cambria" pitchFamily="34" charset="0"/>
+                  <a:ea typeface="Cambria" pitchFamily="34" charset="-122"/>
+                  <a:cs typeface="Cambria" pitchFamily="34" charset="-120"/>
+                </a:rPr>
+                <a:t>02</a:t>
+              </a:r>
+              <a:endParaRPr lang="en-US" sz="2600" dirty="0"/>
+            </a:p>
+          </p:txBody>
+        </p:sp>
+        <p:sp>
+          <p:nvSpPr>
+            <p:cNvPr id="10" name="Text 8"/>
+            <p:cNvSpPr/>
+            <p:nvPr/>
+          </p:nvSpPr>
+          <p:spPr>
+            <a:xfrm>
+              <a:off x="3474720" y="1938528"/>
+              <a:ext cx="2331720" cy="320040"/>
+            </a:xfrm>
+            <a:prstGeom prst="rect">
+              <a:avLst/>
+            </a:prstGeom>
+            <a:noFill/>
+            <a:ln/>
+          </p:spPr>
+          <p:txBody>
+            <a:bodyPr wrap="square" lIns="0" tIns="0" rIns="0" bIns="0" rtlCol="0" anchor="ctr"/>
+            <a:lstStyle/>
+            <a:p>
+              <a:pPr marL="0" indent="0" algn="l">
+                <a:buNone/>
+              </a:pPr>
+              <a:r>
+                <a:rPr lang="en-US" sz="1400" b="1" dirty="0">
+                  <a:solidFill>
+                    <a:srgbClr val="FFFFFF"/>
+                  </a:solidFill>
+                  <a:latin typeface="Cambria" pitchFamily="34" charset="0"/>
+                  <a:ea typeface="Cambria" pitchFamily="34" charset="-122"/>
+                  <a:cs typeface="Cambria" pitchFamily="34" charset="-120"/>
+                </a:rPr>
+                <a:t>Focus, Focus, Focus.</a:t>
+              </a:r>
+              <a:endParaRPr lang="en-US" sz="1400" dirty="0"/>
+            </a:p>
+          </p:txBody>
+        </p:sp>
+        <p:sp>
+          <p:nvSpPr>
+            <p:cNvPr id="11" name="Text 9"/>
+            <p:cNvSpPr/>
+            <p:nvPr/>
+          </p:nvSpPr>
+          <p:spPr>
+            <a:xfrm>
+              <a:off x="3474720" y="2286000"/>
+              <a:ext cx="2331720" cy="1234440"/>
+            </a:xfrm>
+            <a:prstGeom prst="rect">
+              <a:avLst/>
+            </a:prstGeom>
+            <a:noFill/>
+            <a:ln/>
+          </p:spPr>
+          <p:txBody>
+            <a:bodyPr wrap="square" lIns="0" tIns="0" rIns="0" bIns="0" rtlCol="0" anchor="ctr"/>
+            <a:lstStyle/>
+            <a:p>
+              <a:pPr marL="0" indent="0" algn="l">
+                <a:buNone/>
+              </a:pPr>
+              <a:r>
+                <a:rPr lang="en-US" sz="1100" dirty="0">
+                  <a:solidFill>
+                    <a:srgbClr val="B0BEC5"/>
+                  </a:solidFill>
+                  <a:latin typeface="Calibri" pitchFamily="34" charset="0"/>
+                  <a:ea typeface="Calibri" pitchFamily="34" charset="-122"/>
+                  <a:cs typeface="Calibri" pitchFamily="34" charset="-120"/>
+                </a:rPr>
+                <a:t>The data tells a clear story. Customer Success needs clear signals to help with root cause analysis, budget justification and support escalations.</a:t>
+              </a:r>
+            </a:p>
+          </p:txBody>
+        </p:sp>
+      </p:grpSp>
+      <p:grpSp>
+        <p:nvGrpSpPr>
+          <p:cNvPr id="23" name="Group 22">
+            <a:extLst>
+              <a:ext uri="{FF2B5EF4-FFF2-40B4-BE49-F238E27FC236}">
+                <a16:creationId xmlns:a16="http://schemas.microsoft.com/office/drawing/2014/main" id="{F459D4F2-E0F6-7A69-BD7B-3A3F9711F8C4}"/>
+              </a:ext>
+            </a:extLst>
+          </p:cNvPr>
+          <p:cNvGrpSpPr/>
+          <p:nvPr/>
+        </p:nvGrpSpPr>
+        <p:grpSpPr>
           <a:xfrm>
             <a:off x="475488" y="3858768"/>
-            <a:ext cx="8412480" cy="713232"/>
-          </a:xfrm>
-          <a:prstGeom prst="rect">
-            <a:avLst/>
-          </a:prstGeom>
-          <a:solidFill>
-            <a:srgbClr val="B23A48"/>
-          </a:solidFill>
-          <a:ln w="12700">
+            <a:ext cx="8321040" cy="713232"/>
+            <a:chOff x="475488" y="3858768"/>
+            <a:chExt cx="8321040" cy="713232"/>
+          </a:xfrm>
+        </p:grpSpPr>
+        <p:sp>
+          <p:nvSpPr>
+            <p:cNvPr id="16" name="Shape 14"/>
+            <p:cNvSpPr/>
+            <p:nvPr/>
+          </p:nvSpPr>
+          <p:spPr>
+            <a:xfrm>
+              <a:off x="475488" y="3858768"/>
+              <a:ext cx="8321040" cy="713232"/>
+            </a:xfrm>
+            <a:prstGeom prst="rect">
+              <a:avLst/>
+            </a:prstGeom>
             <a:solidFill>
               <a:srgbClr val="B23A48"/>
             </a:solidFill>
-            <a:prstDash val="solid"/>
-          </a:ln>
-        </p:spPr>
-        <p:txBody>
-          <a:bodyPr/>
-          <a:lstStyle/>
-          <a:p>
-            <a:endParaRPr lang="en-DE"/>
-          </a:p>
-        </p:txBody>
-      </p:sp>
-      <p:sp>
-        <p:nvSpPr>
-          <p:cNvPr id="17" name="Text 15"/>
-          <p:cNvSpPr/>
-          <p:nvPr/>
-        </p:nvSpPr>
-        <p:spPr>
-          <a:xfrm>
-            <a:off x="658368" y="3913632"/>
-            <a:ext cx="1097280" cy="201168"/>
-          </a:xfrm>
-          <a:prstGeom prst="rect">
-            <a:avLst/>
-          </a:prstGeom>
-          <a:noFill/>
-          <a:ln/>
-        </p:spPr>
-        <p:txBody>
-          <a:bodyPr wrap="square" lIns="0" tIns="0" rIns="0" bIns="0" rtlCol="0" anchor="ctr"/>
-          <a:lstStyle/>
-          <a:p>
-            <a:pPr marL="0" indent="0" algn="l">
-              <a:buNone/>
-            </a:pPr>
-            <a:r>
-              <a:rPr lang="en-US" sz="900" b="1" kern="0" spc="300" dirty="0">
-                <a:solidFill>
-                  <a:srgbClr val="FFCDD2"/>
-                </a:solidFill>
-                <a:latin typeface="Calibri" pitchFamily="34" charset="0"/>
-                <a:ea typeface="Calibri" pitchFamily="34" charset="-122"/>
-                <a:cs typeface="Calibri" pitchFamily="34" charset="-120"/>
-              </a:rPr>
-              <a:t>THE ASK</a:t>
-            </a:r>
-            <a:endParaRPr lang="en-US" sz="900" dirty="0"/>
-          </a:p>
-        </p:txBody>
-      </p:sp>
-      <p:sp>
-        <p:nvSpPr>
-          <p:cNvPr id="18" name="Text 16"/>
-          <p:cNvSpPr/>
-          <p:nvPr/>
-        </p:nvSpPr>
-        <p:spPr>
-          <a:xfrm>
-            <a:off x="658368" y="4114800"/>
-            <a:ext cx="8302752" cy="320040"/>
-          </a:xfrm>
-          <a:prstGeom prst="rect">
-            <a:avLst/>
-          </a:prstGeom>
-          <a:noFill/>
-          <a:ln/>
-        </p:spPr>
-        <p:txBody>
-          <a:bodyPr wrap="square" lIns="0" tIns="0" rIns="0" bIns="0" rtlCol="0" anchor="ctr"/>
-          <a:lstStyle/>
-          <a:p>
-            <a:pPr marL="0" indent="0" algn="l">
-              <a:buNone/>
-            </a:pPr>
-            <a:r>
-              <a:rPr lang="en-US" sz="1800" b="1" dirty="0">
-                <a:solidFill>
-                  <a:srgbClr val="FFFFFF"/>
-                </a:solidFill>
-                <a:latin typeface="Cambria" pitchFamily="34" charset="0"/>
-                <a:ea typeface="Cambria" pitchFamily="34" charset="-122"/>
-                <a:cs typeface="Cambria" pitchFamily="34" charset="-120"/>
-              </a:rPr>
-              <a:t>Approve the pilot. $8–12K upfront. Test for 6 months. </a:t>
-            </a:r>
-            <a:r>
-              <a:rPr lang="en-US" sz="1800" b="1">
-                <a:solidFill>
-                  <a:srgbClr val="FFFFFF"/>
-                </a:solidFill>
-                <a:latin typeface="Cambria" pitchFamily="34" charset="0"/>
-                <a:ea typeface="Cambria" pitchFamily="34" charset="-122"/>
-                <a:cs typeface="Cambria" pitchFamily="34" charset="-120"/>
-              </a:rPr>
-              <a:t>Then decide</a:t>
-            </a:r>
-            <a:r>
-              <a:rPr lang="en-US" b="1">
-                <a:solidFill>
-                  <a:srgbClr val="FFFFFF"/>
-                </a:solidFill>
-                <a:latin typeface="Cambria" pitchFamily="34" charset="0"/>
-                <a:ea typeface="Cambria" pitchFamily="34" charset="-122"/>
-                <a:cs typeface="Cambria" pitchFamily="34" charset="-120"/>
-              </a:rPr>
-              <a:t> </a:t>
-            </a:r>
-            <a:r>
-              <a:rPr lang="en-US" b="1" dirty="0">
-                <a:solidFill>
-                  <a:srgbClr val="FFFFFF"/>
-                </a:solidFill>
-                <a:latin typeface="Cambria" pitchFamily="34" charset="0"/>
-                <a:ea typeface="Cambria" pitchFamily="34" charset="-122"/>
-                <a:cs typeface="Cambria" pitchFamily="34" charset="-120"/>
-              </a:rPr>
-              <a:t>platform.</a:t>
-            </a:r>
-            <a:endParaRPr lang="en-US" sz="1800" dirty="0"/>
-          </a:p>
-        </p:txBody>
-      </p:sp>
-      <p:sp>
-        <p:nvSpPr>
-          <p:cNvPr id="19" name="Text 17"/>
-          <p:cNvSpPr/>
-          <p:nvPr/>
-        </p:nvSpPr>
-        <p:spPr>
-          <a:xfrm>
-            <a:off x="8503920" y="4754880"/>
-            <a:ext cx="457200" cy="228600"/>
-          </a:xfrm>
-          <a:prstGeom prst="rect">
-            <a:avLst/>
-          </a:prstGeom>
-          <a:noFill/>
-          <a:ln/>
-        </p:spPr>
-        <p:txBody>
-          <a:bodyPr wrap="square" lIns="0" tIns="0" rIns="0" bIns="0" rtlCol="0" anchor="ctr"/>
-          <a:lstStyle/>
-          <a:p>
-            <a:pPr marL="0" indent="0" algn="r">
-              <a:buNone/>
-            </a:pPr>
-            <a:r>
-              <a:rPr lang="en-US" sz="1000" dirty="0">
-                <a:solidFill>
-                  <a:srgbClr val="37474F"/>
-                </a:solidFill>
-                <a:latin typeface="Calibri" pitchFamily="34" charset="0"/>
-                <a:ea typeface="Calibri" pitchFamily="34" charset="-122"/>
-                <a:cs typeface="Calibri" pitchFamily="34" charset="-120"/>
-              </a:rPr>
-              <a:t>07</a:t>
-            </a:r>
-            <a:endParaRPr lang="en-US" sz="1000" dirty="0"/>
-          </a:p>
-        </p:txBody>
-      </p:sp>
+            <a:ln w="12700">
+              <a:solidFill>
+                <a:srgbClr val="B23A48"/>
+              </a:solidFill>
+              <a:prstDash val="solid"/>
+            </a:ln>
+          </p:spPr>
+          <p:txBody>
+            <a:bodyPr/>
+            <a:lstStyle/>
+            <a:p>
+              <a:endParaRPr lang="en-DE"/>
+            </a:p>
+          </p:txBody>
+        </p:sp>
+        <p:sp>
+          <p:nvSpPr>
+            <p:cNvPr id="17" name="Text 15"/>
+            <p:cNvSpPr/>
+            <p:nvPr/>
+          </p:nvSpPr>
+          <p:spPr>
+            <a:xfrm>
+              <a:off x="658368" y="3913632"/>
+              <a:ext cx="1097280" cy="201168"/>
+            </a:xfrm>
+            <a:prstGeom prst="rect">
+              <a:avLst/>
+            </a:prstGeom>
+            <a:noFill/>
+            <a:ln/>
+          </p:spPr>
+          <p:txBody>
+            <a:bodyPr wrap="square" lIns="0" tIns="0" rIns="0" bIns="0" rtlCol="0" anchor="ctr"/>
+            <a:lstStyle/>
+            <a:p>
+              <a:pPr marL="0" indent="0" algn="l">
+                <a:buNone/>
+              </a:pPr>
+              <a:r>
+                <a:rPr lang="en-US" sz="900" b="1" kern="0" spc="300" dirty="0">
+                  <a:solidFill>
+                    <a:srgbClr val="FFCDD2"/>
+                  </a:solidFill>
+                  <a:latin typeface="Calibri" pitchFamily="34" charset="0"/>
+                  <a:ea typeface="Calibri" pitchFamily="34" charset="-122"/>
+                  <a:cs typeface="Calibri" pitchFamily="34" charset="-120"/>
+                </a:rPr>
+                <a:t>THE ASK</a:t>
+              </a:r>
+              <a:endParaRPr lang="en-US" sz="900" dirty="0"/>
+            </a:p>
+          </p:txBody>
+        </p:sp>
+        <p:sp>
+          <p:nvSpPr>
+            <p:cNvPr id="18" name="Text 16"/>
+            <p:cNvSpPr/>
+            <p:nvPr/>
+          </p:nvSpPr>
+          <p:spPr>
+            <a:xfrm>
+              <a:off x="658368" y="4114800"/>
+              <a:ext cx="8138160" cy="320040"/>
+            </a:xfrm>
+            <a:prstGeom prst="rect">
+              <a:avLst/>
+            </a:prstGeom>
+            <a:noFill/>
+            <a:ln/>
+          </p:spPr>
+          <p:txBody>
+            <a:bodyPr wrap="square" lIns="0" tIns="0" rIns="0" bIns="0" rtlCol="0" anchor="ctr"/>
+            <a:lstStyle/>
+            <a:p>
+              <a:pPr marL="0" indent="0" algn="l">
+                <a:buNone/>
+              </a:pPr>
+              <a:r>
+                <a:rPr lang="en-US" sz="1800" b="1" dirty="0">
+                  <a:solidFill>
+                    <a:srgbClr val="FFFFFF"/>
+                  </a:solidFill>
+                  <a:latin typeface="Cambria" pitchFamily="34" charset="0"/>
+                  <a:ea typeface="Cambria" pitchFamily="34" charset="-122"/>
+                  <a:cs typeface="Cambria" pitchFamily="34" charset="-120"/>
+                </a:rPr>
+                <a:t>Approve the 6-week pilot. $8–12K upfront. Test 6 months. Decide</a:t>
+              </a:r>
+              <a:r>
+                <a:rPr lang="en-US" b="1" dirty="0">
+                  <a:solidFill>
+                    <a:srgbClr val="FFFFFF"/>
+                  </a:solidFill>
+                  <a:latin typeface="Cambria" pitchFamily="34" charset="0"/>
+                  <a:ea typeface="Cambria" pitchFamily="34" charset="-122"/>
+                  <a:cs typeface="Cambria" pitchFamily="34" charset="-120"/>
+                </a:rPr>
+                <a:t> platform.</a:t>
+              </a:r>
+              <a:endParaRPr lang="en-US" sz="1800" dirty="0"/>
+            </a:p>
+          </p:txBody>
+        </p:sp>
+      </p:grpSp>
+      <p:grpSp>
+        <p:nvGrpSpPr>
+          <p:cNvPr id="22" name="Group 21">
+            <a:extLst>
+              <a:ext uri="{FF2B5EF4-FFF2-40B4-BE49-F238E27FC236}">
+                <a16:creationId xmlns:a16="http://schemas.microsoft.com/office/drawing/2014/main" id="{15F84079-1CD0-7FDC-F971-9CB6C1F190B3}"/>
+              </a:ext>
+            </a:extLst>
+          </p:cNvPr>
+          <p:cNvGrpSpPr/>
+          <p:nvPr/>
+        </p:nvGrpSpPr>
+        <p:grpSpPr>
+          <a:xfrm>
+            <a:off x="6144768" y="1325880"/>
+            <a:ext cx="2651760" cy="2377440"/>
+            <a:chOff x="6144768" y="1325880"/>
+            <a:chExt cx="2651760" cy="2377440"/>
+          </a:xfrm>
+        </p:grpSpPr>
+        <p:sp>
+          <p:nvSpPr>
+            <p:cNvPr id="12" name="Shape 10"/>
+            <p:cNvSpPr/>
+            <p:nvPr/>
+          </p:nvSpPr>
+          <p:spPr>
+            <a:xfrm>
+              <a:off x="6144768" y="1325880"/>
+              <a:ext cx="2651760" cy="2377440"/>
+            </a:xfrm>
+            <a:prstGeom prst="rect">
+              <a:avLst/>
+            </a:prstGeom>
+            <a:solidFill>
+              <a:srgbClr val="163A5A"/>
+            </a:solidFill>
+            <a:ln w="12700">
+              <a:solidFill>
+                <a:srgbClr val="2E74B5"/>
+              </a:solidFill>
+              <a:prstDash val="solid"/>
+            </a:ln>
+            <a:effectLst>
+              <a:outerShdw blurRad="101600" dist="38100" dir="8100000" algn="bl" rotWithShape="0">
+                <a:srgbClr val="000000">
+                  <a:alpha val="10000"/>
+                </a:srgbClr>
+              </a:outerShdw>
+            </a:effectLst>
+          </p:spPr>
+          <p:txBody>
+            <a:bodyPr/>
+            <a:lstStyle/>
+            <a:p>
+              <a:endParaRPr lang="en-DE"/>
+            </a:p>
+          </p:txBody>
+        </p:sp>
+        <p:sp>
+          <p:nvSpPr>
+            <p:cNvPr id="13" name="Text 11"/>
+            <p:cNvSpPr/>
+            <p:nvPr/>
+          </p:nvSpPr>
+          <p:spPr>
+            <a:xfrm>
+              <a:off x="6309360" y="1444752"/>
+              <a:ext cx="594360" cy="457200"/>
+            </a:xfrm>
+            <a:prstGeom prst="rect">
+              <a:avLst/>
+            </a:prstGeom>
+            <a:noFill/>
+            <a:ln/>
+          </p:spPr>
+          <p:txBody>
+            <a:bodyPr wrap="square" lIns="0" tIns="0" rIns="0" bIns="0" rtlCol="0" anchor="ctr"/>
+            <a:lstStyle/>
+            <a:p>
+              <a:pPr marL="0" indent="0" algn="l">
+                <a:buNone/>
+              </a:pPr>
+              <a:r>
+                <a:rPr lang="en-US" sz="2600" b="1" dirty="0">
+                  <a:solidFill>
+                    <a:srgbClr val="2E74B5"/>
+                  </a:solidFill>
+                  <a:latin typeface="Cambria" pitchFamily="34" charset="0"/>
+                  <a:ea typeface="Cambria" pitchFamily="34" charset="-122"/>
+                  <a:cs typeface="Cambria" pitchFamily="34" charset="-120"/>
+                </a:rPr>
+                <a:t>03</a:t>
+              </a:r>
+              <a:endParaRPr lang="en-US" sz="2600" dirty="0"/>
+            </a:p>
+          </p:txBody>
+        </p:sp>
+        <p:sp>
+          <p:nvSpPr>
+            <p:cNvPr id="14" name="Text 12"/>
+            <p:cNvSpPr/>
+            <p:nvPr/>
+          </p:nvSpPr>
+          <p:spPr>
+            <a:xfrm>
+              <a:off x="6309360" y="1938528"/>
+              <a:ext cx="2331720" cy="320040"/>
+            </a:xfrm>
+            <a:prstGeom prst="rect">
+              <a:avLst/>
+            </a:prstGeom>
+            <a:noFill/>
+            <a:ln/>
+          </p:spPr>
+          <p:txBody>
+            <a:bodyPr wrap="square" lIns="0" tIns="0" rIns="0" bIns="0" rtlCol="0" anchor="ctr"/>
+            <a:lstStyle/>
+            <a:p>
+              <a:pPr marL="0" indent="0" algn="l">
+                <a:buNone/>
+              </a:pPr>
+              <a:r>
+                <a:rPr lang="en-US" sz="1400" b="1" dirty="0">
+                  <a:solidFill>
+                    <a:srgbClr val="FFFFFF"/>
+                  </a:solidFill>
+                  <a:latin typeface="Cambria" pitchFamily="34" charset="0"/>
+                  <a:ea typeface="Cambria" pitchFamily="34" charset="-122"/>
+                  <a:cs typeface="Cambria" pitchFamily="34" charset="-120"/>
+                </a:rPr>
+                <a:t>Iteration is key to success.</a:t>
+              </a:r>
+              <a:endParaRPr lang="en-US" sz="1400" dirty="0"/>
+            </a:p>
+          </p:txBody>
+        </p:sp>
+        <p:sp>
+          <p:nvSpPr>
+            <p:cNvPr id="15" name="Text 13"/>
+            <p:cNvSpPr/>
+            <p:nvPr/>
+          </p:nvSpPr>
+          <p:spPr>
+            <a:xfrm>
+              <a:off x="6309360" y="2286000"/>
+              <a:ext cx="2331720" cy="1234440"/>
+            </a:xfrm>
+            <a:prstGeom prst="rect">
+              <a:avLst/>
+            </a:prstGeom>
+            <a:noFill/>
+            <a:ln/>
+          </p:spPr>
+          <p:txBody>
+            <a:bodyPr wrap="square" lIns="0" tIns="0" rIns="0" bIns="0" rtlCol="0" anchor="ctr"/>
+            <a:lstStyle/>
+            <a:p>
+              <a:pPr marL="0" indent="0" algn="l">
+                <a:buNone/>
+              </a:pPr>
+              <a:r>
+                <a:rPr lang="en-US" sz="1100" dirty="0">
+                  <a:solidFill>
+                    <a:srgbClr val="B0BEC5"/>
+                  </a:solidFill>
+                  <a:latin typeface="Calibri" pitchFamily="34" charset="0"/>
+                  <a:ea typeface="Calibri" pitchFamily="34" charset="-122"/>
+                  <a:cs typeface="Calibri" pitchFamily="34" charset="-120"/>
+                </a:rPr>
+                <a:t>$8–12K internal pilot with a go/no-go at Phase 1 protects you from an uninformed decision that locks you into $300k+ investment.</a:t>
+              </a:r>
+              <a:endParaRPr lang="en-US" sz="1100" dirty="0"/>
+            </a:p>
+          </p:txBody>
+        </p:sp>
+        <p:sp>
+          <p:nvSpPr>
+            <p:cNvPr id="19" name="Text 17"/>
+            <p:cNvSpPr/>
+            <p:nvPr/>
+          </p:nvSpPr>
+          <p:spPr>
+            <a:xfrm>
+              <a:off x="6598164" y="2985516"/>
+              <a:ext cx="457200" cy="228600"/>
+            </a:xfrm>
+            <a:prstGeom prst="rect">
+              <a:avLst/>
+            </a:prstGeom>
+            <a:noFill/>
+            <a:ln/>
+          </p:spPr>
+          <p:txBody>
+            <a:bodyPr wrap="square" lIns="0" tIns="0" rIns="0" bIns="0" rtlCol="0" anchor="ctr"/>
+            <a:lstStyle/>
+            <a:p>
+              <a:pPr marL="0" indent="0" algn="r">
+                <a:buNone/>
+              </a:pPr>
+              <a:r>
+                <a:rPr lang="en-US" sz="1000" dirty="0">
+                  <a:solidFill>
+                    <a:srgbClr val="37474F"/>
+                  </a:solidFill>
+                  <a:latin typeface="Calibri" pitchFamily="34" charset="0"/>
+                  <a:ea typeface="Calibri" pitchFamily="34" charset="-122"/>
+                  <a:cs typeface="Calibri" pitchFamily="34" charset="-120"/>
+                </a:rPr>
+                <a:t>07</a:t>
+              </a:r>
+              <a:endParaRPr lang="en-US" sz="1000" dirty="0"/>
+            </a:p>
+          </p:txBody>
+        </p:sp>
+      </p:grpSp>
     </p:spTree>
   </p:cSld>
   <p:clrMapOvr>
     <a:masterClrMapping/>
   </p:clrMapOvr>
+  <p:timing>
+    <p:tnLst>
+      <p:par>
+        <p:cTn id="1" dur="indefinite" restart="never" nodeType="tmRoot">
+          <p:childTnLst>
+            <p:seq concurrent="1" nextAc="seek">
+              <p:cTn id="2" dur="indefinite" nodeType="mainSeq">
+                <p:childTnLst>
+                  <p:par>
+                    <p:cTn id="3" fill="hold">
+                      <p:stCondLst>
+                        <p:cond delay="indefinite"/>
+                      </p:stCondLst>
+                      <p:childTnLst>
+                        <p:par>
+                          <p:cTn id="4" fill="hold">
+                            <p:stCondLst>
+                              <p:cond delay="0"/>
+                            </p:stCondLst>
+                            <p:childTnLst>
+                              <p:par>
+                                <p:cTn id="5" presetID="1" presetClass="entr" presetSubtype="0" fill="hold" nodeType="clickEffect">
+                                  <p:stCondLst>
+                                    <p:cond delay="0"/>
+                                  </p:stCondLst>
+                                  <p:childTnLst>
+                                    <p:set>
+                                      <p:cBhvr>
+                                        <p:cTn id="6" dur="1" fill="hold">
+                                          <p:stCondLst>
+                                            <p:cond delay="0"/>
+                                          </p:stCondLst>
+                                        </p:cTn>
+                                        <p:tgtEl>
+                                          <p:spTgt spid="20"/>
+                                        </p:tgtEl>
+                                        <p:attrNameLst>
+                                          <p:attrName>style.visibility</p:attrName>
+                                        </p:attrNameLst>
+                                      </p:cBhvr>
+                                      <p:to>
+                                        <p:strVal val="visible"/>
+                                      </p:to>
+                                    </p:set>
+                                  </p:childTnLst>
+                                </p:cTn>
+                              </p:par>
+                            </p:childTnLst>
+                          </p:cTn>
+                        </p:par>
+                      </p:childTnLst>
+                    </p:cTn>
+                  </p:par>
+                  <p:par>
+                    <p:cTn id="7" fill="hold">
+                      <p:stCondLst>
+                        <p:cond delay="indefinite"/>
+                      </p:stCondLst>
+                      <p:childTnLst>
+                        <p:par>
+                          <p:cTn id="8" fill="hold">
+                            <p:stCondLst>
+                              <p:cond delay="0"/>
+                            </p:stCondLst>
+                            <p:childTnLst>
+                              <p:par>
+                                <p:cTn id="9" presetID="1" presetClass="entr" presetSubtype="0" fill="hold" nodeType="clickEffect">
+                                  <p:stCondLst>
+                                    <p:cond delay="0"/>
+                                  </p:stCondLst>
+                                  <p:childTnLst>
+                                    <p:set>
+                                      <p:cBhvr>
+                                        <p:cTn id="10" dur="1" fill="hold">
+                                          <p:stCondLst>
+                                            <p:cond delay="0"/>
+                                          </p:stCondLst>
+                                        </p:cTn>
+                                        <p:tgtEl>
+                                          <p:spTgt spid="21"/>
+                                        </p:tgtEl>
+                                        <p:attrNameLst>
+                                          <p:attrName>style.visibility</p:attrName>
+                                        </p:attrNameLst>
+                                      </p:cBhvr>
+                                      <p:to>
+                                        <p:strVal val="visible"/>
+                                      </p:to>
+                                    </p:set>
+                                  </p:childTnLst>
+                                </p:cTn>
+                              </p:par>
+                            </p:childTnLst>
+                          </p:cTn>
+                        </p:par>
+                      </p:childTnLst>
+                    </p:cTn>
+                  </p:par>
+                  <p:par>
+                    <p:cTn id="11" fill="hold">
+                      <p:stCondLst>
+                        <p:cond delay="indefinite"/>
+                      </p:stCondLst>
+                      <p:childTnLst>
+                        <p:par>
+                          <p:cTn id="12" fill="hold">
+                            <p:stCondLst>
+                              <p:cond delay="0"/>
+                            </p:stCondLst>
+                            <p:childTnLst>
+                              <p:par>
+                                <p:cTn id="13" presetID="1" presetClass="entr" presetSubtype="0" fill="hold" nodeType="clickEffect">
+                                  <p:stCondLst>
+                                    <p:cond delay="0"/>
+                                  </p:stCondLst>
+                                  <p:childTnLst>
+                                    <p:set>
+                                      <p:cBhvr>
+                                        <p:cTn id="14" dur="1" fill="hold">
+                                          <p:stCondLst>
+                                            <p:cond delay="0"/>
+                                          </p:stCondLst>
+                                        </p:cTn>
+                                        <p:tgtEl>
+                                          <p:spTgt spid="22"/>
+                                        </p:tgtEl>
+                                        <p:attrNameLst>
+                                          <p:attrName>style.visibility</p:attrName>
+                                        </p:attrNameLst>
+                                      </p:cBhvr>
+                                      <p:to>
+                                        <p:strVal val="visible"/>
+                                      </p:to>
+                                    </p:set>
+                                  </p:childTnLst>
+                                </p:cTn>
+                              </p:par>
+                            </p:childTnLst>
+                          </p:cTn>
+                        </p:par>
+                      </p:childTnLst>
+                    </p:cTn>
+                  </p:par>
+                  <p:par>
+                    <p:cTn id="15" fill="hold">
+                      <p:stCondLst>
+                        <p:cond delay="indefinite"/>
+                      </p:stCondLst>
+                      <p:childTnLst>
+                        <p:par>
+                          <p:cTn id="16" fill="hold">
+                            <p:stCondLst>
+                              <p:cond delay="0"/>
+                            </p:stCondLst>
+                            <p:childTnLst>
+                              <p:par>
+                                <p:cTn id="17" presetID="1" presetClass="entr" presetSubtype="0" fill="hold" nodeType="clickEffect">
+                                  <p:stCondLst>
+                                    <p:cond delay="0"/>
+                                  </p:stCondLst>
+                                  <p:childTnLst>
+                                    <p:set>
+                                      <p:cBhvr>
+                                        <p:cTn id="18" dur="1" fill="hold">
+                                          <p:stCondLst>
+                                            <p:cond delay="0"/>
+                                          </p:stCondLst>
+                                        </p:cTn>
+                                        <p:tgtEl>
+                                          <p:spTgt spid="23"/>
+                                        </p:tgtEl>
+                                        <p:attrNameLst>
+                                          <p:attrName>style.visibility</p:attrName>
+                                        </p:attrNameLst>
+                                      </p:cBhvr>
+                                      <p:to>
+                                        <p:strVal val="visible"/>
+                                      </p:to>
+                                    </p:set>
+                                  </p:childTnLst>
+                                </p:cTn>
+                              </p:par>
+                            </p:childTnLst>
+                          </p:cTn>
+                        </p:par>
+                      </p:childTnLst>
+                    </p:cTn>
+                  </p:par>
+                </p:childTnLst>
+              </p:cTn>
+              <p:prevCondLst>
+                <p:cond evt="onPrev" delay="0">
+                  <p:tgtEl>
+                    <p:sldTgt/>
+                  </p:tgtEl>
+                </p:cond>
+              </p:prevCondLst>
+              <p:nextCondLst>
+                <p:cond evt="onNext" delay="0">
+                  <p:tgtEl>
+                    <p:sldTgt/>
+                  </p:tgtEl>
+                </p:cond>
+              </p:nextCondLst>
+            </p:seq>
+          </p:childTnLst>
+        </p:cTn>
+      </p:par>
+    </p:tnLst>
+  </p:timing>
 </p:sld>
 </file>
 

</xml_diff>